<commit_message>
Update presentation with 1-2 exact graphs per slide and comprehensive explanations
</commit_message>
<xml_diff>
--- a/Food_Delivery_Time_Prediction_Presentation.pptx
+++ b/Food_Delivery_Time_Prediction_Presentation.pptx
@@ -3176,7 +3176,6 @@
                 <a:solidFill>
                   <a:srgbClr val="0284C7"/>
                 </a:solidFill>
-                <a:latin typeface="Arial"/>
               </a:defRPr>
             </a:pPr>
             <a:r>
@@ -3192,7 +3191,6 @@
                 <a:solidFill>
                   <a:srgbClr val="FFFFFF"/>
                 </a:solidFill>
-                <a:latin typeface="Arial"/>
               </a:defRPr>
             </a:pPr>
             <a:r>
@@ -3208,11 +3206,10 @@
                 <a:solidFill>
                   <a:srgbClr val="CBD5E1"/>
                 </a:solidFill>
-                <a:latin typeface="Arial"/>
-              </a:defRPr>
-            </a:pPr>
-            <a:r>
-              <a:t>End-to-End Machine Learning Regression Pipeline, Outlier Sensitivity Analysis, and Web Deployment</a:t>
+              </a:defRPr>
+            </a:pPr>
+            <a:r>
+              <a:t>End-to-End Regression Modeling, Outlier Sensitivity Analysis, and Web Deployment</a:t>
             </a:r>
           </a:p>
           <a:p>
@@ -3221,11 +3218,10 @@
                 <a:solidFill>
                   <a:srgbClr val="64748B"/>
                 </a:solidFill>
-                <a:latin typeface="Arial"/>
-              </a:defRPr>
-            </a:pPr>
-            <a:r>
-              <a:t>Student Project Presentation | Department of Computer Science &amp; Engineering | Semester V</a:t>
+              </a:defRPr>
+            </a:pPr>
+            <a:r>
+              <a:t>Comprehensive Visual Project Presentation | Machine Learning (Semester V)</a:t>
             </a:r>
           </a:p>
         </p:txBody>
@@ -3256,7 +3252,7 @@
         </p:nvSpPr>
         <p:spPr>
           <a:xfrm>
-            <a:off x="731520" y="365760"/>
+            <a:off x="731520" y="320040"/>
             <a:ext cx="10698480" cy="1005840"/>
           </a:xfrm>
           <a:prstGeom prst="rect">
@@ -3272,7 +3268,7 @@
           <a:p>
             <a:pPr>
               <a:spcAft>
-                <a:spcPts val="400"/>
+                <a:spcPts val="200"/>
               </a:spcAft>
               <a:defRPr sz="1000" b="1">
                 <a:solidFill>
@@ -3287,7 +3283,7 @@
           </a:p>
           <a:p>
             <a:pPr>
-              <a:defRPr sz="2200" b="1">
+              <a:defRPr sz="2100" b="1">
                 <a:solidFill>
                   <a:srgbClr val="0F172A"/>
                 </a:solidFill>
@@ -3295,14 +3291,14 @@
               </a:defRPr>
             </a:pPr>
             <a:r>
-              <a:t>In-Depth Study: MAE vs RMSE &amp; Outlier Delay Sensitivity</a:t>
+              <a:t>In-Depth Comparative Study: MAE vs RMSE and Outlier Sensitivity</a:t>
             </a:r>
           </a:p>
         </p:txBody>
       </p:sp>
       <p:pic>
         <p:nvPicPr>
-          <p:cNvPr id="3" name="Picture 2" descr="6_mae_vs_rmse_outliers.png"/>
+          <p:cNvPr id="3" name="Picture 2" descr="11_outlier_divergence.png"/>
           <p:cNvPicPr>
             <a:picLocks noChangeAspect="1"/>
           </p:cNvPicPr>
@@ -3316,8 +3312,8 @@
         </p:blipFill>
         <p:spPr>
           <a:xfrm>
-            <a:off x="731520" y="1645920"/>
-            <a:ext cx="5852160" cy="3258056"/>
+            <a:off x="731520" y="1417320"/>
+            <a:ext cx="6217920" cy="3602513"/>
           </a:xfrm>
           <a:prstGeom prst="rect">
             <a:avLst/>
@@ -3332,8 +3328,8 @@
         </p:nvSpPr>
         <p:spPr>
           <a:xfrm>
-            <a:off x="6766560" y="1645920"/>
-            <a:ext cx="4663440" cy="4572000"/>
+            <a:off x="7223760" y="1417320"/>
+            <a:ext cx="4206240" cy="4937760"/>
           </a:xfrm>
           <a:prstGeom prst="rect">
             <a:avLst/>
@@ -3377,8 +3373,8 @@
         </p:nvSpPr>
         <p:spPr>
           <a:xfrm>
-            <a:off x="6949440" y="1828800"/>
-            <a:ext cx="4297680" cy="4206240"/>
+            <a:off x="7452360" y="1645920"/>
+            <a:ext cx="3749040" cy="4480560"/>
           </a:xfrm>
           <a:prstGeom prst="rect">
             <a:avLst/>
@@ -3393,7 +3389,7 @@
           <a:p>
             <a:pPr>
               <a:spcAft>
-                <a:spcPts val="1000"/>
+                <a:spcPts val="1200"/>
               </a:spcAft>
               <a:defRPr sz="1600" b="1">
                 <a:solidFill>
@@ -3408,54 +3404,54 @@
           <a:p>
             <a:pPr>
               <a:spcAft>
-                <a:spcPts val="500"/>
-              </a:spcAft>
-              <a:defRPr sz="1050">
+                <a:spcPts val="800"/>
+              </a:spcAft>
+              <a:defRPr sz="1100">
                 <a:solidFill>
                   <a:srgbClr val="1E293B"/>
                 </a:solidFill>
               </a:defRPr>
             </a:pPr>
             <a:r>
-              <a:t>- Mathematical Core: MAE penalizes errors linearly (e_i = |y - y_hat|), whereas RMSE squares individual deviations (e_i^2).</a:t>
-            </a:r>
-          </a:p>
-          <a:p>
-            <a:pPr>
-              <a:spcAft>
-                <a:spcPts val="500"/>
-              </a:spcAft>
-              <a:defRPr sz="1050">
+              <a:t>- Mathematical Formulation: MAE penalizes deviations linearly: e_i = |y - y_hat|. RMSE squares individual deviations: e_i^2.</a:t>
+            </a:r>
+          </a:p>
+          <a:p>
+            <a:pPr>
+              <a:spcAft>
+                <a:spcPts val="800"/>
+              </a:spcAft>
+              <a:defRPr sz="1100">
                 <a:solidFill>
                   <a:srgbClr val="1E293B"/>
                 </a:solidFill>
               </a:defRPr>
             </a:pPr>
             <a:r>
-              <a:t>- Outlier Amplification: A single order delayed by 60 mins creates an error of 60 in MAE space, but 3,600 in squared MSE space!</a:t>
-            </a:r>
-          </a:p>
-          <a:p>
-            <a:pPr>
-              <a:spcAft>
-                <a:spcPts val="500"/>
-              </a:spcAft>
-              <a:defRPr sz="1050">
+              <a:t>- Quadratic Inflation: An isolated delay of 60 minutes contributes 60 to MAE, but 3,600 to squared error space (MSE/RMSE)!</a:t>
+            </a:r>
+          </a:p>
+          <a:p>
+            <a:pPr>
+              <a:spcAft>
+                <a:spcPts val="800"/>
+              </a:spcAft>
+              <a:defRPr sz="1100">
                 <a:solidFill>
                   <a:srgbClr val="1E293B"/>
                 </a:solidFill>
               </a:defRPr>
             </a:pPr>
             <a:r>
-              <a:t>- Empirical Proof: When tested on raw delayed orders:</a:t>
-            </a:r>
-          </a:p>
-          <a:p>
-            <a:pPr>
-              <a:spcAft>
-                <a:spcPts val="500"/>
-              </a:spcAft>
-              <a:defRPr sz="1050">
+              <a:t>- Empirical Evidence from Graph 11: When evaluated on raw delayed orders:</a:t>
+            </a:r>
+          </a:p>
+          <a:p>
+            <a:pPr>
+              <a:spcAft>
+                <a:spcPts val="800"/>
+              </a:spcAft>
+              <a:defRPr sz="1100">
                 <a:solidFill>
                   <a:srgbClr val="1E293B"/>
                 </a:solidFill>
@@ -3468,9 +3464,9 @@
           <a:p>
             <a:pPr>
               <a:spcAft>
-                <a:spcPts val="500"/>
-              </a:spcAft>
-              <a:defRPr sz="1050">
+                <a:spcPts val="800"/>
+              </a:spcAft>
+              <a:defRPr sz="1100">
                 <a:solidFill>
                   <a:srgbClr val="1E293B"/>
                 </a:solidFill>
@@ -3483,31 +3479,31 @@
           <a:p>
             <a:pPr>
               <a:spcAft>
-                <a:spcPts val="500"/>
-              </a:spcAft>
-              <a:defRPr sz="1050">
+                <a:spcPts val="800"/>
+              </a:spcAft>
+              <a:defRPr sz="1100">
                 <a:solidFill>
                   <a:srgbClr val="1E293B"/>
                 </a:solidFill>
               </a:defRPr>
             </a:pPr>
             <a:r>
-              <a:t>- Customer Perception: Customers perceive delivery delays on a linear scale. An operational promise of +/- 5 mins is intuitive and meaningful.</a:t>
-            </a:r>
-          </a:p>
-          <a:p>
-            <a:pPr>
-              <a:spcAft>
-                <a:spcPts val="500"/>
-              </a:spcAft>
-              <a:defRPr sz="1050">
+              <a:t>- Customer Expectation Alignment: Food delivery customers perceive ETA error linearly. Telling a customer 'our delivery is within +/- 5 mins on average' is meaningful and accurate.</a:t>
+            </a:r>
+          </a:p>
+          <a:p>
+            <a:pPr>
+              <a:spcAft>
+                <a:spcPts val="800"/>
+              </a:spcAft>
+              <a:defRPr sz="1100">
                 <a:solidFill>
                   <a:srgbClr val="1E293B"/>
                 </a:solidFill>
               </a:defRPr>
             </a:pPr>
             <a:r>
-              <a:t>- Decision: MAE is the primary benchmark for delivery estimation because isolated black-swan delays (flat tires, kitchen fires) unfairly corrupt RMSE.</a:t>
+              <a:t>- Operational Conclusion: MAE is the superior primary metric because isolated black-swan events (flat tire, kitchen breakdown) unfairly dominate and distort RMSE.</a:t>
             </a:r>
           </a:p>
         </p:txBody>
@@ -3538,7 +3534,7 @@
         </p:nvSpPr>
         <p:spPr>
           <a:xfrm>
-            <a:off x="731520" y="365760"/>
+            <a:off x="731520" y="320040"/>
             <a:ext cx="10698480" cy="1005840"/>
           </a:xfrm>
           <a:prstGeom prst="rect">
@@ -3554,7 +3550,7 @@
           <a:p>
             <a:pPr>
               <a:spcAft>
-                <a:spcPts val="400"/>
+                <a:spcPts val="200"/>
               </a:spcAft>
               <a:defRPr sz="1000" b="1">
                 <a:solidFill>
@@ -3569,7 +3565,7 @@
           </a:p>
           <a:p>
             <a:pPr>
-              <a:defRPr sz="2200" b="1">
+              <a:defRPr sz="2100" b="1">
                 <a:solidFill>
                   <a:srgbClr val="0F172A"/>
                 </a:solidFill>
@@ -3584,7 +3580,7 @@
       </p:sp>
       <p:pic>
         <p:nvPicPr>
-          <p:cNvPr id="3" name="Picture 2" descr="7_residual_analysis.png"/>
+          <p:cNvPr id="3" name="Picture 2" descr="12_residuals_scatter.png"/>
           <p:cNvPicPr>
             <a:picLocks noChangeAspect="1"/>
           </p:cNvPicPr>
@@ -3598,8 +3594,8 @@
         </p:blipFill>
         <p:spPr>
           <a:xfrm>
-            <a:off x="731520" y="1645920"/>
-            <a:ext cx="6766560" cy="2730221"/>
+            <a:off x="731520" y="1417320"/>
+            <a:ext cx="5120640" cy="3442897"/>
           </a:xfrm>
           <a:prstGeom prst="rect">
             <a:avLst/>
@@ -3614,8 +3610,8 @@
         </p:nvSpPr>
         <p:spPr>
           <a:xfrm>
-            <a:off x="7680960" y="1645920"/>
-            <a:ext cx="3749039" cy="4572000"/>
+            <a:off x="731520" y="4709160"/>
+            <a:ext cx="5120640" cy="1828800"/>
           </a:xfrm>
           <a:prstGeom prst="rect">
             <a:avLst/>
@@ -3659,8 +3655,8 @@
         </p:nvSpPr>
         <p:spPr>
           <a:xfrm>
-            <a:off x="7863840" y="1828800"/>
-            <a:ext cx="3383280" cy="4206240"/>
+            <a:off x="914400" y="4818888"/>
+            <a:ext cx="4754880" cy="1609344"/>
           </a:xfrm>
           <a:prstGeom prst="rect">
             <a:avLst/>
@@ -3675,76 +3671,213 @@
           <a:p>
             <a:pPr>
               <a:spcAft>
-                <a:spcPts val="1000"/>
-              </a:spcAft>
-              <a:defRPr sz="1600" b="1">
+                <a:spcPts val="400"/>
+              </a:spcAft>
+              <a:defRPr sz="1200" b="1">
                 <a:solidFill>
                   <a:srgbClr val="0F172A"/>
                 </a:solidFill>
               </a:defRPr>
             </a:pPr>
             <a:r>
-              <a:t>Validation of Assumptions</a:t>
-            </a:r>
-          </a:p>
-          <a:p>
-            <a:pPr>
-              <a:spcAft>
-                <a:spcPts val="800"/>
-              </a:spcAft>
-              <a:defRPr sz="1100">
+              <a:t>Graph 12: Residuals vs Predicted Values</a:t>
+            </a:r>
+          </a:p>
+          <a:p>
+            <a:pPr>
+              <a:spcAft>
+                <a:spcPts val="300"/>
+              </a:spcAft>
+              <a:defRPr sz="1000">
                 <a:solidFill>
                   <a:srgbClr val="1E293B"/>
                 </a:solidFill>
               </a:defRPr>
             </a:pPr>
             <a:r>
-              <a:t>- 1. Homoscedasticity: The residual scatter plot shows consistent, uniform variance across the entire predicted ETA spectrum (20 to 75 mins). No cone-shaped heteroscedasticity is observed.</a:t>
-            </a:r>
-          </a:p>
-          <a:p>
-            <a:pPr>
-              <a:spcAft>
-                <a:spcPts val="800"/>
-              </a:spcAft>
-              <a:defRPr sz="1100">
+              <a:t>- Homoscedasticity Verified: Residual scatter remains uniformly dispersed across the entire predicted ETA spectrum.</a:t>
+            </a:r>
+          </a:p>
+          <a:p>
+            <a:pPr>
+              <a:spcAft>
+                <a:spcPts val="300"/>
+              </a:spcAft>
+              <a:defRPr sz="1000">
                 <a:solidFill>
                   <a:srgbClr val="1E293B"/>
                 </a:solidFill>
               </a:defRPr>
             </a:pPr>
             <a:r>
-              <a:t>- 2. Zero-Mean Error: The mean residual error is 0.003 minutes, confirming that model predictions are completely unbiased.</a:t>
-            </a:r>
-          </a:p>
-          <a:p>
-            <a:pPr>
-              <a:spcAft>
-                <a:spcPts val="800"/>
-              </a:spcAft>
-              <a:defRPr sz="1100">
+              <a:t>- No Cone-Shaped Variance: Error spread is consistent whether predicting short (20 min) or long (70 min) deliveries.</a:t>
+            </a:r>
+          </a:p>
+          <a:p>
+            <a:pPr>
+              <a:spcAft>
+                <a:spcPts val="300"/>
+              </a:spcAft>
+              <a:defRPr sz="1000">
                 <a:solidFill>
                   <a:srgbClr val="1E293B"/>
                 </a:solidFill>
               </a:defRPr>
             </a:pPr>
             <a:r>
-              <a:t>- 3. Normal Distribution: The residual histogram aligns closely with a Gaussian bell curve centered at zero.</a:t>
-            </a:r>
-          </a:p>
-          <a:p>
-            <a:pPr>
-              <a:spcAft>
-                <a:spcPts val="800"/>
-              </a:spcAft>
-              <a:defRPr sz="1100">
+              <a:t>- Zero Systematic Pattern: Red dashed line at zero shows random scatter with no non-linear curvature.</a:t>
+            </a:r>
+          </a:p>
+        </p:txBody>
+      </p:sp>
+      <p:pic>
+        <p:nvPicPr>
+          <p:cNvPr id="6" name="Picture 5" descr="13_residuals_distribution.png"/>
+          <p:cNvPicPr>
+            <a:picLocks noChangeAspect="1"/>
+          </p:cNvPicPr>
+          <p:nvPr/>
+        </p:nvPicPr>
+        <p:blipFill>
+          <a:blip r:embed="rId3"/>
+          <a:stretch>
+            <a:fillRect/>
+          </a:stretch>
+        </p:blipFill>
+        <p:spPr>
+          <a:xfrm>
+            <a:off x="6309360" y="1417320"/>
+            <a:ext cx="5120640" cy="3432517"/>
+          </a:xfrm>
+          <a:prstGeom prst="rect">
+            <a:avLst/>
+          </a:prstGeom>
+        </p:spPr>
+      </p:pic>
+      <p:sp>
+        <p:nvSpPr>
+          <p:cNvPr id="7" name="Rectangle 6"/>
+          <p:cNvSpPr/>
+          <p:nvPr/>
+        </p:nvSpPr>
+        <p:spPr>
+          <a:xfrm>
+            <a:off x="6309360" y="4709160"/>
+            <a:ext cx="5120640" cy="1828800"/>
+          </a:xfrm>
+          <a:prstGeom prst="rect">
+            <a:avLst/>
+          </a:prstGeom>
+          <a:solidFill>
+            <a:srgbClr val="F8FAFC"/>
+          </a:solidFill>
+          <a:ln w="12700">
+            <a:solidFill>
+              <a:srgbClr val="E2E8F0"/>
+            </a:solidFill>
+          </a:ln>
+        </p:spPr>
+        <p:style>
+          <a:lnRef idx="1">
+            <a:schemeClr val="accent1"/>
+          </a:lnRef>
+          <a:fillRef idx="3">
+            <a:schemeClr val="accent1"/>
+          </a:fillRef>
+          <a:effectRef idx="2">
+            <a:schemeClr val="accent1"/>
+          </a:effectRef>
+          <a:fontRef idx="minor">
+            <a:schemeClr val="lt1"/>
+          </a:fontRef>
+        </p:style>
+        <p:txBody>
+          <a:bodyPr rtlCol="0" anchor="ctr"/>
+          <a:lstStyle/>
+          <a:p>
+            <a:pPr algn="ctr"/>
+          </a:p>
+        </p:txBody>
+      </p:sp>
+      <p:sp>
+        <p:nvSpPr>
+          <p:cNvPr id="8" name="TextBox 7"/>
+          <p:cNvSpPr txBox="1"/>
+          <p:nvPr/>
+        </p:nvSpPr>
+        <p:spPr>
+          <a:xfrm>
+            <a:off x="6492240" y="4818888"/>
+            <a:ext cx="4754880" cy="1609344"/>
+          </a:xfrm>
+          <a:prstGeom prst="rect">
+            <a:avLst/>
+          </a:prstGeom>
+          <a:noFill/>
+        </p:spPr>
+        <p:txBody>
+          <a:bodyPr wrap="square">
+            <a:spAutoFit/>
+          </a:bodyPr>
+          <a:lstStyle/>
+          <a:p>
+            <a:pPr>
+              <a:spcAft>
+                <a:spcPts val="400"/>
+              </a:spcAft>
+              <a:defRPr sz="1200" b="1">
+                <a:solidFill>
+                  <a:srgbClr val="0F172A"/>
+                </a:solidFill>
+              </a:defRPr>
+            </a:pPr>
+            <a:r>
+              <a:t>Graph 13: Residual Error Distribution</a:t>
+            </a:r>
+          </a:p>
+          <a:p>
+            <a:pPr>
+              <a:spcAft>
+                <a:spcPts val="300"/>
+              </a:spcAft>
+              <a:defRPr sz="1000">
                 <a:solidFill>
                   <a:srgbClr val="1E293B"/>
                 </a:solidFill>
               </a:defRPr>
             </a:pPr>
             <a:r>
-              <a:t>- 4. No Systematic Bias: Errors are randomly distributed, confirming that the model extracted all learnable structural signals from the predictors.</a:t>
+              <a:t>- Gaussian Error Normality: Residual distribution closely matches a symmetric bell curve centered at zero.</a:t>
+            </a:r>
+          </a:p>
+          <a:p>
+            <a:pPr>
+              <a:spcAft>
+                <a:spcPts val="300"/>
+              </a:spcAft>
+              <a:defRPr sz="1000">
+                <a:solidFill>
+                  <a:srgbClr val="1E293B"/>
+                </a:solidFill>
+              </a:defRPr>
+            </a:pPr>
+            <a:r>
+              <a:t>- Unbiased Predictions: The mean residual error is 0.003 minutes, confirming that predictions are globally unbiased.</a:t>
+            </a:r>
+          </a:p>
+          <a:p>
+            <a:pPr>
+              <a:spcAft>
+                <a:spcPts val="300"/>
+              </a:spcAft>
+              <a:defRPr sz="1000">
+                <a:solidFill>
+                  <a:srgbClr val="1E293B"/>
+                </a:solidFill>
+              </a:defRPr>
+            </a:pPr>
+            <a:r>
+              <a:t>- Signal Exhaustion: Confirms that the model successfully extracted all learnable structural signals from the dataset.</a:t>
             </a:r>
           </a:p>
         </p:txBody>
@@ -3775,7 +3908,7 @@
         </p:nvSpPr>
         <p:spPr>
           <a:xfrm>
-            <a:off x="731520" y="365760"/>
+            <a:off x="731520" y="320040"/>
             <a:ext cx="10698480" cy="1005840"/>
           </a:xfrm>
           <a:prstGeom prst="rect">
@@ -3791,7 +3924,7 @@
           <a:p>
             <a:pPr>
               <a:spcAft>
-                <a:spcPts val="400"/>
+                <a:spcPts val="200"/>
               </a:spcAft>
               <a:defRPr sz="1000" b="1">
                 <a:solidFill>
@@ -3806,7 +3939,7 @@
           </a:p>
           <a:p>
             <a:pPr>
-              <a:defRPr sz="2200" b="1">
+              <a:defRPr sz="2100" b="1">
                 <a:solidFill>
                   <a:srgbClr val="0F172A"/>
                 </a:solidFill>
@@ -3814,14 +3947,14 @@
               </a:defRPr>
             </a:pPr>
             <a:r>
-              <a:t>Feature Importance: Identifying Key Operational Drivers</a:t>
+              <a:t>Feature Importance: Identifying Key Operational Determinants</a:t>
             </a:r>
           </a:p>
         </p:txBody>
       </p:sp>
       <p:pic>
         <p:nvPicPr>
-          <p:cNvPr id="3" name="Picture 2" descr="8_feature_importance.png"/>
+          <p:cNvPr id="3" name="Picture 2" descr="14_feature_importance.png"/>
           <p:cNvPicPr>
             <a:picLocks noChangeAspect="1"/>
           </p:cNvPicPr>
@@ -3835,8 +3968,8 @@
         </p:blipFill>
         <p:spPr>
           <a:xfrm>
-            <a:off x="731520" y="1645920"/>
-            <a:ext cx="6217920" cy="3078640"/>
+            <a:off x="731520" y="1417320"/>
+            <a:ext cx="6217920" cy="3610678"/>
           </a:xfrm>
           <a:prstGeom prst="rect">
             <a:avLst/>
@@ -3851,8 +3984,8 @@
         </p:nvSpPr>
         <p:spPr>
           <a:xfrm>
-            <a:off x="7132320" y="1645920"/>
-            <a:ext cx="4297680" cy="4572000"/>
+            <a:off x="7223760" y="1417320"/>
+            <a:ext cx="4206240" cy="4937760"/>
           </a:xfrm>
           <a:prstGeom prst="rect">
             <a:avLst/>
@@ -3896,8 +4029,8 @@
         </p:nvSpPr>
         <p:spPr>
           <a:xfrm>
-            <a:off x="7315200" y="1828800"/>
-            <a:ext cx="3931920" cy="4206240"/>
+            <a:off x="7452360" y="1645920"/>
+            <a:ext cx="3749040" cy="4480560"/>
           </a:xfrm>
           <a:prstGeom prst="rect">
             <a:avLst/>
@@ -3912,7 +4045,7 @@
           <a:p>
             <a:pPr>
               <a:spcAft>
-                <a:spcPts val="1000"/>
+                <a:spcPts val="1200"/>
               </a:spcAft>
               <a:defRPr sz="1600" b="1">
                 <a:solidFill>
@@ -3921,13 +4054,13 @@
               </a:defRPr>
             </a:pPr>
             <a:r>
-              <a:t>Operational Factor Rankings</a:t>
-            </a:r>
-          </a:p>
-          <a:p>
-            <a:pPr>
-              <a:spcAft>
-                <a:spcPts val="700"/>
+              <a:t>Operational Drivers Breakdown</a:t>
+            </a:r>
+          </a:p>
+          <a:p>
+            <a:pPr>
+              <a:spcAft>
+                <a:spcPts val="800"/>
               </a:spcAft>
               <a:defRPr sz="1100">
                 <a:solidFill>
@@ -3936,13 +4069,13 @@
               </a:defRPr>
             </a:pPr>
             <a:r>
-              <a:t>- 1. Trip Distance (~48% Importance): The dominant predictive factor determining baseline transit time.</a:t>
-            </a:r>
-          </a:p>
-          <a:p>
-            <a:pPr>
-              <a:spcAft>
-                <a:spcPts val="700"/>
+              <a:t>- 1. Trip Distance (~48% Relative Weight): The single largest factor governing order duration. Direct driver of baseline transit kilometers.</a:t>
+            </a:r>
+          </a:p>
+          <a:p>
+            <a:pPr>
+              <a:spcAft>
+                <a:spcPts val="800"/>
               </a:spcAft>
               <a:defRPr sz="1100">
                 <a:solidFill>
@@ -3951,13 +4084,13 @@
               </a:defRPr>
             </a:pPr>
             <a:r>
-              <a:t>- 2. Traffic Congestion (~24% Importance): 'Jam' and 'High' traffic conditions create the largest friction multiplier.</a:t>
-            </a:r>
-          </a:p>
-          <a:p>
-            <a:pPr>
-              <a:spcAft>
-                <a:spcPts val="700"/>
+              <a:t>- 2. Traffic Congestion (~24% Relative Weight): 'Jam' and 'High' congestion act as massive friction multipliers on transit velocity.</a:t>
+            </a:r>
+          </a:p>
+          <a:p>
+            <a:pPr>
+              <a:spcAft>
+                <a:spcPts val="800"/>
               </a:spcAft>
               <a:defRPr sz="1100">
                 <a:solidFill>
@@ -3966,13 +4099,13 @@
               </a:defRPr>
             </a:pPr>
             <a:r>
-              <a:t>- 3. Kitchen Prep Time (~18% Importance): Critical operational bottleneck; accurate kitchen telemetry is essential.</a:t>
-            </a:r>
-          </a:p>
-          <a:p>
-            <a:pPr>
-              <a:spcAft>
-                <a:spcPts val="700"/>
+              <a:t>- 3. Kitchen Preparation Time (~18% Relative Weight): Critical pre-dispatch operational bottleneck.</a:t>
+            </a:r>
+          </a:p>
+          <a:p>
+            <a:pPr>
+              <a:spcAft>
+                <a:spcPts val="800"/>
               </a:spcAft>
               <a:defRPr sz="1100">
                 <a:solidFill>
@@ -3981,13 +4114,13 @@
               </a:defRPr>
             </a:pPr>
             <a:r>
-              <a:t>- 4. Weather Conditions (~7% Importance): Stormy and Rainy conditions add non-trivial friction.</a:t>
-            </a:r>
-          </a:p>
-          <a:p>
-            <a:pPr>
-              <a:spcAft>
-                <a:spcPts val="700"/>
+              <a:t>- 4. Weather Conditions (~7% Relative Weight): Storm and Rain conditions contribute non-trivial delays to courier speed.</a:t>
+            </a:r>
+          </a:p>
+          <a:p>
+            <a:pPr>
+              <a:spcAft>
+                <a:spcPts val="800"/>
               </a:spcAft>
               <a:defRPr sz="1100">
                 <a:solidFill>
@@ -4002,7 +4135,7 @@
           <a:p>
             <a:pPr>
               <a:spcAft>
-                <a:spcPts val="700"/>
+                <a:spcPts val="800"/>
               </a:spcAft>
               <a:defRPr sz="1100">
                 <a:solidFill>
@@ -4011,7 +4144,7 @@
               </a:defRPr>
             </a:pPr>
             <a:r>
-              <a:t>- Strategic Conclusion: Delivery platforms should prioritize intelligent routing and real-time kitchen readiness to optimize customer ETAs.</a:t>
+              <a:t>- Operational Takeaway: Food platforms can achieve maximum ETA accuracy gains by integrating live traffic telemetry and dynamic kitchen readiness tracking.</a:t>
             </a:r>
           </a:p>
         </p:txBody>
@@ -4042,7 +4175,7 @@
         </p:nvSpPr>
         <p:spPr>
           <a:xfrm>
-            <a:off x="731520" y="365760"/>
+            <a:off x="731520" y="320040"/>
             <a:ext cx="10698480" cy="1005840"/>
           </a:xfrm>
           <a:prstGeom prst="rect">
@@ -4058,7 +4191,7 @@
           <a:p>
             <a:pPr>
               <a:spcAft>
-                <a:spcPts val="400"/>
+                <a:spcPts val="200"/>
               </a:spcAft>
               <a:defRPr sz="1000" b="1">
                 <a:solidFill>
@@ -4073,7 +4206,7 @@
           </a:p>
           <a:p>
             <a:pPr>
-              <a:defRPr sz="2200" b="1">
+              <a:defRPr sz="2100" b="1">
                 <a:solidFill>
                   <a:srgbClr val="0F172A"/>
                 </a:solidFill>
@@ -4094,8 +4227,8 @@
         </p:nvSpPr>
         <p:spPr>
           <a:xfrm>
-            <a:off x="731520" y="1645920"/>
-            <a:ext cx="3328416" cy="4572000"/>
+            <a:off x="731520" y="1463040"/>
+            <a:ext cx="3328416" cy="4846320"/>
           </a:xfrm>
           <a:prstGeom prst="rect">
             <a:avLst/>
@@ -4139,8 +4272,8 @@
         </p:nvSpPr>
         <p:spPr>
           <a:xfrm>
-            <a:off x="914400" y="1828800"/>
-            <a:ext cx="2962656" cy="4206240"/>
+            <a:off x="914400" y="1645920"/>
+            <a:ext cx="2962656" cy="4480560"/>
           </a:xfrm>
           <a:prstGeom prst="rect">
             <a:avLst/>
@@ -4157,7 +4290,7 @@
               <a:spcAft>
                 <a:spcPts val="1200"/>
               </a:spcAft>
-              <a:defRPr sz="1500" b="1">
+              <a:defRPr sz="1600" b="1">
                 <a:solidFill>
                   <a:srgbClr val="0F172A"/>
                 </a:solidFill>
@@ -4209,7 +4342,7 @@
               </a:defRPr>
             </a:pPr>
             <a:r>
-              <a:t>- Pre-processing: Dynamic categorical encoding and standard scaling</a:t>
+              <a:t>- Pre-processing: Dynamic categorical dummy encoding and standard scaling</a:t>
             </a:r>
           </a:p>
           <a:p>
@@ -4224,7 +4357,7 @@
               </a:defRPr>
             </a:pPr>
             <a:r>
-              <a:t>- Execution Model: Server-side real-time calculation with cached resources</a:t>
+              <a:t>- Caching: @st.cache_resource ensures the model is loaded only once in memory</a:t>
             </a:r>
           </a:p>
         </p:txBody>
@@ -4237,8 +4370,8 @@
         </p:nvSpPr>
         <p:spPr>
           <a:xfrm>
-            <a:off x="4425696" y="1645920"/>
-            <a:ext cx="3328416" cy="4572000"/>
+            <a:off x="4425696" y="1463040"/>
+            <a:ext cx="3328416" cy="4846320"/>
           </a:xfrm>
           <a:prstGeom prst="rect">
             <a:avLst/>
@@ -4282,8 +4415,8 @@
         </p:nvSpPr>
         <p:spPr>
           <a:xfrm>
-            <a:off x="4608576" y="1828800"/>
-            <a:ext cx="2962656" cy="4206240"/>
+            <a:off x="4608576" y="1645920"/>
+            <a:ext cx="2962656" cy="4480560"/>
           </a:xfrm>
           <a:prstGeom prst="rect">
             <a:avLst/>
@@ -4300,14 +4433,14 @@
               <a:spcAft>
                 <a:spcPts val="1200"/>
               </a:spcAft>
-              <a:defRPr sz="1500" b="1">
+              <a:defRPr sz="1600" b="1">
                 <a:solidFill>
                   <a:srgbClr val="0F172A"/>
                 </a:solidFill>
               </a:defRPr>
             </a:pPr>
             <a:r>
-              <a:t>User Interface Features</a:t>
+              <a:t>User Interface Controls</a:t>
             </a:r>
           </a:p>
           <a:p>
@@ -4322,7 +4455,7 @@
               </a:defRPr>
             </a:pPr>
             <a:r>
-              <a:t>- Interactive Inputs: Sliders for Distance &amp; Kitchen Prep; dropdowns for Traffic, Weather, Schedule</a:t>
+              <a:t>- Interactive Inputs: Sliders for Distance (0.5-25 km) &amp; Kitchen Prep (5-50 min)</a:t>
             </a:r>
           </a:p>
           <a:p>
@@ -4337,7 +4470,7 @@
               </a:defRPr>
             </a:pPr>
             <a:r>
-              <a:t>- Primary Output: Instant Predicted ETA in minutes</a:t>
+              <a:t>- Environmental Inputs: Dropdowns for Traffic Level, Weather Condition, Time of Day, and Partner Rating</a:t>
             </a:r>
           </a:p>
           <a:p>
@@ -4352,7 +4485,7 @@
               </a:defRPr>
             </a:pPr>
             <a:r>
-              <a:t>- Operational Window: Dynamic confidence interval (ETA +/- MAE)</a:t>
+              <a:t>- Primary Output: Large, clear ETA display in minutes</a:t>
             </a:r>
           </a:p>
           <a:p>
@@ -4367,7 +4500,22 @@
               </a:defRPr>
             </a:pPr>
             <a:r>
-              <a:t>- Visible Toggle Controls: Priority Courier Dispatch switch and Detail View toggle</a:t>
+              <a:t>- Confidence Window: Dynamic operational window (ETA +/- MAE)</a:t>
+            </a:r>
+          </a:p>
+          <a:p>
+            <a:pPr>
+              <a:spcAft>
+                <a:spcPts val="800"/>
+              </a:spcAft>
+              <a:defRPr sz="1100">
+                <a:solidFill>
+                  <a:srgbClr val="1E293B"/>
+                </a:solidFill>
+              </a:defRPr>
+            </a:pPr>
+            <a:r>
+              <a:t>- Visible Toggles: Priority Dispatch switch (-15% transit buffer) and Detail View toggle</a:t>
             </a:r>
           </a:p>
         </p:txBody>
@@ -4380,8 +4528,8 @@
         </p:nvSpPr>
         <p:spPr>
           <a:xfrm>
-            <a:off x="8119872" y="1645920"/>
-            <a:ext cx="3328416" cy="4572000"/>
+            <a:off x="8119872" y="1463040"/>
+            <a:ext cx="3328416" cy="4846320"/>
           </a:xfrm>
           <a:prstGeom prst="rect">
             <a:avLst/>
@@ -4425,8 +4573,8 @@
         </p:nvSpPr>
         <p:spPr>
           <a:xfrm>
-            <a:off x="8302752" y="1828800"/>
-            <a:ext cx="2962656" cy="4206240"/>
+            <a:off x="8302752" y="1645920"/>
+            <a:ext cx="2962656" cy="4480560"/>
           </a:xfrm>
           <a:prstGeom prst="rect">
             <a:avLst/>
@@ -4443,7 +4591,7 @@
               <a:spcAft>
                 <a:spcPts val="1200"/>
               </a:spcAft>
-              <a:defRPr sz="1500" b="1">
+              <a:defRPr sz="1600" b="1">
                 <a:solidFill>
                   <a:srgbClr val="0F172A"/>
                 </a:solidFill>
@@ -4465,7 +4613,7 @@
               </a:defRPr>
             </a:pPr>
             <a:r>
-              <a:t>- Version Control: Full project committed and pushed to GitHub (Rizwan2611/food-delivery-time-prediction)</a:t>
+              <a:t>- Source Control: GitHub repository (Rizwan2611/food-delivery-time-prediction)</a:t>
             </a:r>
           </a:p>
           <a:p>
@@ -4480,7 +4628,7 @@
               </a:defRPr>
             </a:pPr>
             <a:r>
-              <a:t>- Hosting: Streamlit Community Cloud (Free public cloud deployment)</a:t>
+              <a:t>- Cloud Host: Streamlit Community Cloud (Free public web hosting)</a:t>
             </a:r>
           </a:p>
           <a:p>
@@ -4495,7 +4643,7 @@
               </a:defRPr>
             </a:pPr>
             <a:r>
-              <a:t>- Continuous Deployment: Automatic hot-reload on every Git push</a:t>
+              <a:t>- Automated CI/CD: Instant hot-reloading on every GitHub push</a:t>
             </a:r>
           </a:p>
           <a:p>
@@ -4510,7 +4658,7 @@
               </a:defRPr>
             </a:pPr>
             <a:r>
-              <a:t>- Public Access: Live web URL accessible across desktop and mobile devices</a:t>
+              <a:t>- Production URL: Publicly accessible across desktop and mobile devices</a:t>
             </a:r>
           </a:p>
         </p:txBody>
@@ -4541,7 +4689,7 @@
         </p:nvSpPr>
         <p:spPr>
           <a:xfrm>
-            <a:off x="731520" y="365760"/>
+            <a:off x="731520" y="320040"/>
             <a:ext cx="10698480" cy="1005840"/>
           </a:xfrm>
           <a:prstGeom prst="rect">
@@ -4557,7 +4705,7 @@
           <a:p>
             <a:pPr>
               <a:spcAft>
-                <a:spcPts val="400"/>
+                <a:spcPts val="200"/>
               </a:spcAft>
               <a:defRPr sz="1000" b="1">
                 <a:solidFill>
@@ -4572,7 +4720,7 @@
           </a:p>
           <a:p>
             <a:pPr>
-              <a:defRPr sz="2200" b="1">
+              <a:defRPr sz="2100" b="1">
                 <a:solidFill>
                   <a:srgbClr val="0F172A"/>
                 </a:solidFill>
@@ -4580,7 +4728,7 @@
               </a:defRPr>
             </a:pPr>
             <a:r>
-              <a:t>Solutions to Case Study Questions: Questions 1 to 4</a:t>
+              <a:t>Empirical Solutions to Case Study Questions (1 to 4)</a:t>
             </a:r>
           </a:p>
         </p:txBody>
@@ -4593,8 +4741,8 @@
         </p:nvSpPr>
         <p:spPr>
           <a:xfrm>
-            <a:off x="731520" y="1645920"/>
-            <a:ext cx="10698480" cy="1005840"/>
+            <a:off x="731520" y="1463040"/>
+            <a:ext cx="10698480" cy="1051560"/>
           </a:xfrm>
           <a:prstGeom prst="rect">
             <a:avLst/>
@@ -4638,8 +4786,8 @@
         </p:nvSpPr>
         <p:spPr>
           <a:xfrm>
-            <a:off x="914400" y="1719072"/>
-            <a:ext cx="10332720" cy="859536"/>
+            <a:off x="914400" y="1554480"/>
+            <a:ext cx="10332720" cy="868680"/>
           </a:xfrm>
           <a:prstGeom prst="rect">
             <a:avLst/>
@@ -4688,8 +4836,8 @@
         </p:nvSpPr>
         <p:spPr>
           <a:xfrm>
-            <a:off x="731520" y="2761488"/>
-            <a:ext cx="10698480" cy="1005840"/>
+            <a:off x="731520" y="2651760"/>
+            <a:ext cx="10698480" cy="1051560"/>
           </a:xfrm>
           <a:prstGeom prst="rect">
             <a:avLst/>
@@ -4733,8 +4881,8 @@
         </p:nvSpPr>
         <p:spPr>
           <a:xfrm>
-            <a:off x="914400" y="2834640"/>
-            <a:ext cx="10332720" cy="859536"/>
+            <a:off x="914400" y="2743200"/>
+            <a:ext cx="10332720" cy="868680"/>
           </a:xfrm>
           <a:prstGeom prst="rect">
             <a:avLst/>
@@ -4783,8 +4931,8 @@
         </p:nvSpPr>
         <p:spPr>
           <a:xfrm>
-            <a:off x="731520" y="3877056"/>
-            <a:ext cx="10698480" cy="1005840"/>
+            <a:off x="731520" y="3840480"/>
+            <a:ext cx="10698480" cy="1051560"/>
           </a:xfrm>
           <a:prstGeom prst="rect">
             <a:avLst/>
@@ -4828,8 +4976,8 @@
         </p:nvSpPr>
         <p:spPr>
           <a:xfrm>
-            <a:off x="914400" y="3950208"/>
-            <a:ext cx="10332720" cy="859536"/>
+            <a:off x="914400" y="3931920"/>
+            <a:ext cx="10332720" cy="868680"/>
           </a:xfrm>
           <a:prstGeom prst="rect">
             <a:avLst/>
@@ -4878,8 +5026,8 @@
         </p:nvSpPr>
         <p:spPr>
           <a:xfrm>
-            <a:off x="731520" y="4992624"/>
-            <a:ext cx="10698480" cy="1005840"/>
+            <a:off x="731520" y="5029200"/>
+            <a:ext cx="10698480" cy="1051560"/>
           </a:xfrm>
           <a:prstGeom prst="rect">
             <a:avLst/>
@@ -4923,8 +5071,8 @@
         </p:nvSpPr>
         <p:spPr>
           <a:xfrm>
-            <a:off x="914400" y="5065776"/>
-            <a:ext cx="10332720" cy="859536"/>
+            <a:off x="914400" y="5120640"/>
+            <a:ext cx="10332720" cy="868680"/>
           </a:xfrm>
           <a:prstGeom prst="rect">
             <a:avLst/>
@@ -4991,7 +5139,7 @@
         </p:nvSpPr>
         <p:spPr>
           <a:xfrm>
-            <a:off x="731520" y="365760"/>
+            <a:off x="731520" y="320040"/>
             <a:ext cx="10698480" cy="1005840"/>
           </a:xfrm>
           <a:prstGeom prst="rect">
@@ -5007,7 +5155,7 @@
           <a:p>
             <a:pPr>
               <a:spcAft>
-                <a:spcPts val="400"/>
+                <a:spcPts val="200"/>
               </a:spcAft>
               <a:defRPr sz="1000" b="1">
                 <a:solidFill>
@@ -5022,7 +5170,7 @@
           </a:p>
           <a:p>
             <a:pPr>
-              <a:defRPr sz="2200" b="1">
+              <a:defRPr sz="2100" b="1">
                 <a:solidFill>
                   <a:srgbClr val="0F172A"/>
                 </a:solidFill>
@@ -5030,7 +5178,7 @@
               </a:defRPr>
             </a:pPr>
             <a:r>
-              <a:t>Solutions to Case Study Questions: Questions 5 to 7 &amp; Limitations</a:t>
+              <a:t>Empirical Solutions to Questions (5 to 7) &amp; Limitations</a:t>
             </a:r>
           </a:p>
         </p:txBody>
@@ -5043,8 +5191,8 @@
         </p:nvSpPr>
         <p:spPr>
           <a:xfrm>
-            <a:off x="731520" y="1645920"/>
-            <a:ext cx="10698480" cy="987552"/>
+            <a:off x="731520" y="1463040"/>
+            <a:ext cx="10698480" cy="1024128"/>
           </a:xfrm>
           <a:prstGeom prst="rect">
             <a:avLst/>
@@ -5088,7 +5236,7 @@
         </p:nvSpPr>
         <p:spPr>
           <a:xfrm>
-            <a:off x="914400" y="1719072"/>
+            <a:off x="914400" y="1554480"/>
             <a:ext cx="10332720" cy="841248"/>
           </a:xfrm>
           <a:prstGeom prst="rect">
@@ -5138,8 +5286,8 @@
         </p:nvSpPr>
         <p:spPr>
           <a:xfrm>
-            <a:off x="731520" y="2743200"/>
-            <a:ext cx="10698480" cy="987552"/>
+            <a:off x="731520" y="2606040"/>
+            <a:ext cx="10698480" cy="1024128"/>
           </a:xfrm>
           <a:prstGeom prst="rect">
             <a:avLst/>
@@ -5183,7 +5331,7 @@
         </p:nvSpPr>
         <p:spPr>
           <a:xfrm>
-            <a:off x="914400" y="2816352"/>
+            <a:off x="914400" y="2697480"/>
             <a:ext cx="10332720" cy="841248"/>
           </a:xfrm>
           <a:prstGeom prst="rect">
@@ -5233,8 +5381,8 @@
         </p:nvSpPr>
         <p:spPr>
           <a:xfrm>
-            <a:off x="731520" y="3840480"/>
-            <a:ext cx="10698480" cy="987552"/>
+            <a:off x="731520" y="3749040"/>
+            <a:ext cx="10698480" cy="1024128"/>
           </a:xfrm>
           <a:prstGeom prst="rect">
             <a:avLst/>
@@ -5278,7 +5426,7 @@
         </p:nvSpPr>
         <p:spPr>
           <a:xfrm>
-            <a:off x="914400" y="3913632"/>
+            <a:off x="914400" y="3840480"/>
             <a:ext cx="10332720" cy="841248"/>
           </a:xfrm>
           <a:prstGeom prst="rect">
@@ -5398,7 +5546,7 @@
               </a:defRPr>
             </a:pPr>
             <a:r>
-              <a:t>Real-World Operational Limitations &amp; Future Enhancements</a:t>
+              <a:t>Real-World Limitations: Static Models vs. Real-Time Telemetry</a:t>
             </a:r>
           </a:p>
           <a:p>
@@ -5410,7 +5558,7 @@
               </a:defRPr>
             </a:pPr>
             <a:r>
-              <a:t>Static vs Real-Time GPS: The model currently relies on discrete categorical traffic levels rather than live GPS telemetry. Sudden micro-weather changes, elevator delays in high-rise buildings, and restaurant kitchen queue bottlenecks cannot be fully captured without real-time IoT integration.</a:t>
+              <a:t>Static vs GPS Telemetry: Static models categorize traffic into discrete levels rather than live route segments. Uncontrollable micro-events (elevator waits in high-rises, restaurant kitchen queue backlogs, sudden cloudbursts) create residual variance that requires real-time IoT integration.</a:t>
             </a:r>
           </a:p>
         </p:txBody>
@@ -5441,7 +5589,7 @@
         </p:nvSpPr>
         <p:spPr>
           <a:xfrm>
-            <a:off x="731520" y="365760"/>
+            <a:off x="731520" y="320040"/>
             <a:ext cx="10698480" cy="1005840"/>
           </a:xfrm>
           <a:prstGeom prst="rect">
@@ -5457,7 +5605,7 @@
           <a:p>
             <a:pPr>
               <a:spcAft>
-                <a:spcPts val="400"/>
+                <a:spcPts val="200"/>
               </a:spcAft>
               <a:defRPr sz="1000" b="1">
                 <a:solidFill>
@@ -5472,7 +5620,7 @@
           </a:p>
           <a:p>
             <a:pPr>
-              <a:defRPr sz="2200" b="1">
+              <a:defRPr sz="2100" b="1">
                 <a:solidFill>
                   <a:srgbClr val="0F172A"/>
                 </a:solidFill>
@@ -5493,8 +5641,8 @@
         </p:nvSpPr>
         <p:spPr>
           <a:xfrm>
-            <a:off x="731520" y="1645920"/>
-            <a:ext cx="5175504" cy="4572000"/>
+            <a:off x="731520" y="1463040"/>
+            <a:ext cx="5175504" cy="4846320"/>
           </a:xfrm>
           <a:prstGeom prst="rect">
             <a:avLst/>
@@ -5538,8 +5686,8 @@
         </p:nvSpPr>
         <p:spPr>
           <a:xfrm>
-            <a:off x="914400" y="1828800"/>
-            <a:ext cx="4809744" cy="4206240"/>
+            <a:off x="914400" y="1645920"/>
+            <a:ext cx="4809744" cy="4480560"/>
           </a:xfrm>
           <a:prstGeom prst="rect">
             <a:avLst/>
@@ -5578,7 +5726,7 @@
               </a:defRPr>
             </a:pPr>
             <a:r>
-              <a:t>- Developed a complete end-to-end Machine Learning regression pipeline conforming to B.Tech CSE Semester V guidelines.</a:t>
+              <a:t>- Full Compliance: Completed every phase specified in B.Tech CSE Semester V Case Study 30.</a:t>
             </a:r>
           </a:p>
           <a:p>
@@ -5593,7 +5741,7 @@
               </a:defRPr>
             </a:pPr>
             <a:r>
-              <a:t>- Addressed real-world data issues: dynamic mode imputation for missing data and IQR-based Winsorization for severe delay outliers.</a:t>
+              <a:t>- Robust Data Pipeline: Dynamic mode imputation for missing data and IQR-based Winsorization for severe delay outliers.</a:t>
             </a:r>
           </a:p>
           <a:p>
@@ -5608,7 +5756,7 @@
               </a:defRPr>
             </a:pPr>
             <a:r>
-              <a:t>- Implemented and tuned 5 algorithms: Linear, Polynomial (Deg 2), Decision Tree, Random Forest, and Gradient Boosting.</a:t>
+              <a:t>- 5 Algorithm Benchmark: Evaluated Linear, Polynomial (Deg 2), Decision Tree, Random Forest, and Gradient Boosting.</a:t>
             </a:r>
           </a:p>
           <a:p>
@@ -5623,7 +5771,7 @@
               </a:defRPr>
             </a:pPr>
             <a:r>
-              <a:t>- Conducted rigorous evaluation via R2, MSE, RMSE, MAE, and 5-Fold Cross-Validation.</a:t>
+              <a:t>- Evaluation Rigor: Compared models via R2, MSE, RMSE, MAE, and 5-Fold Cross-Validation.</a:t>
             </a:r>
           </a:p>
           <a:p>
@@ -5638,7 +5786,7 @@
               </a:defRPr>
             </a:pPr>
             <a:r>
-              <a:t>- Validated all linear regression assumptions via diagnostic residual plots.</a:t>
+              <a:t>- Assumption Validation: Validated linear regression assumptions using homoscedasticity and residual normality plots.</a:t>
             </a:r>
           </a:p>
         </p:txBody>
@@ -5651,8 +5799,8 @@
         </p:nvSpPr>
         <p:spPr>
           <a:xfrm>
-            <a:off x="6272784" y="1645920"/>
-            <a:ext cx="5175504" cy="4572000"/>
+            <a:off x="6272784" y="1463040"/>
+            <a:ext cx="5175504" cy="4846320"/>
           </a:xfrm>
           <a:prstGeom prst="rect">
             <a:avLst/>
@@ -5696,8 +5844,8 @@
         </p:nvSpPr>
         <p:spPr>
           <a:xfrm>
-            <a:off x="6455664" y="1828800"/>
-            <a:ext cx="4809744" cy="4206240"/>
+            <a:off x="6455664" y="1645920"/>
+            <a:ext cx="4809744" cy="4480560"/>
           </a:xfrm>
           <a:prstGeom prst="rect">
             <a:avLst/>
@@ -5736,7 +5884,7 @@
               </a:defRPr>
             </a:pPr>
             <a:r>
-              <a:t>- Proven Metric Reliability: Established conclusively why MAE is the preferred customer metric over RMSE for food delivery platforms.</a:t>
+              <a:t>- Metric Rationale: Conclusively proved why MAE is the superior customer-facing metric over RMSE.</a:t>
             </a:r>
           </a:p>
           <a:p>
@@ -5751,7 +5899,7 @@
               </a:defRPr>
             </a:pPr>
             <a:r>
-              <a:t>- Feature Insights: Distance and Traffic Congestion account for &gt;70% of delivery duration variance.</a:t>
+              <a:t>- Operational Drivers: Identified Distance (~48%) and Traffic Congestion (~24%) as the primary drivers of order duration.</a:t>
             </a:r>
           </a:p>
           <a:p>
@@ -5766,7 +5914,7 @@
               </a:defRPr>
             </a:pPr>
             <a:r>
-              <a:t>- Production Ready: Deployed the trained pipeline into an interactive, emoji-free web interface using Streamlit.</a:t>
+              <a:t>- Production Ready: Deployed the trained model as an interactive, clean Streamlit web application.</a:t>
             </a:r>
           </a:p>
           <a:p>
@@ -5781,7 +5929,7 @@
               </a:defRPr>
             </a:pPr>
             <a:r>
-              <a:t>- Full Reproducibility: Code organized into a clean Jupyter Notebook, serialized model artifact, and GitHub repository ready for cloud hosting.</a:t>
+              <a:t>- Full Open-Source Code: Code, serialized model, and presentation fully synced to GitHub for one-click cloud hosting.</a:t>
             </a:r>
           </a:p>
         </p:txBody>
@@ -5812,7 +5960,7 @@
         </p:nvSpPr>
         <p:spPr>
           <a:xfrm>
-            <a:off x="731520" y="365760"/>
+            <a:off x="731520" y="320040"/>
             <a:ext cx="10698480" cy="1005840"/>
           </a:xfrm>
           <a:prstGeom prst="rect">
@@ -5828,7 +5976,7 @@
           <a:p>
             <a:pPr>
               <a:spcAft>
-                <a:spcPts val="400"/>
+                <a:spcPts val="200"/>
               </a:spcAft>
               <a:defRPr sz="1000" b="1">
                 <a:solidFill>
@@ -5843,7 +5991,7 @@
           </a:p>
           <a:p>
             <a:pPr>
-              <a:defRPr sz="2200" b="1">
+              <a:defRPr sz="2100" b="1">
                 <a:solidFill>
                   <a:srgbClr val="0F172A"/>
                 </a:solidFill>
@@ -5851,7 +5999,7 @@
               </a:defRPr>
             </a:pPr>
             <a:r>
-              <a:t>Executive Summary &amp; Core Project Objectives</a:t>
+              <a:t>Project Background &amp; Technical Workflow</a:t>
             </a:r>
           </a:p>
         </p:txBody>
@@ -5864,8 +6012,8 @@
         </p:nvSpPr>
         <p:spPr>
           <a:xfrm>
-            <a:off x="731520" y="1645920"/>
-            <a:ext cx="3328416" cy="4572000"/>
+            <a:off x="731520" y="1463040"/>
+            <a:ext cx="3328416" cy="4846320"/>
           </a:xfrm>
           <a:prstGeom prst="rect">
             <a:avLst/>
@@ -5909,8 +6057,8 @@
         </p:nvSpPr>
         <p:spPr>
           <a:xfrm>
-            <a:off x="914400" y="1828800"/>
-            <a:ext cx="2962656" cy="4206240"/>
+            <a:off x="914400" y="1645920"/>
+            <a:ext cx="2962656" cy="4480560"/>
           </a:xfrm>
           <a:prstGeom prst="rect">
             <a:avLst/>
@@ -5934,7 +6082,7 @@
               </a:defRPr>
             </a:pPr>
             <a:r>
-              <a:t>Business Context</a:t>
+              <a:t>Business Motivation</a:t>
             </a:r>
           </a:p>
           <a:p>
@@ -5942,14 +6090,14 @@
               <a:spcAft>
                 <a:spcPts val="800"/>
               </a:spcAft>
-              <a:defRPr sz="1200">
+              <a:defRPr sz="1100">
                 <a:solidFill>
                   <a:srgbClr val="1E293B"/>
                 </a:solidFill>
               </a:defRPr>
             </a:pPr>
             <a:r>
-              <a:t>- On-demand food delivery platforms (e.g., Zomato, Swiggy, Uber Eats) rely heavily on precise Estimated Time of Arrival (ETA).</a:t>
+              <a:t>- Customer Retention: Providing accurate Estimated Time of Arrival (ETA) is the single largest driver of food platform loyalty.</a:t>
             </a:r>
           </a:p>
           <a:p>
@@ -5957,14 +6105,14 @@
               <a:spcAft>
                 <a:spcPts val="800"/>
               </a:spcAft>
-              <a:defRPr sz="1200">
+              <a:defRPr sz="1100">
                 <a:solidFill>
                   <a:srgbClr val="1E293B"/>
                 </a:solidFill>
               </a:defRPr>
             </a:pPr>
             <a:r>
-              <a:t>- Inaccurate estimates lead to customer churn, driver dissatisfaction, and dispatch inefficiencies.</a:t>
+              <a:t>- Dispatch Optimization: Accurate kitchen and transit predictions reduce idle courier wait times.</a:t>
             </a:r>
           </a:p>
           <a:p>
@@ -5972,14 +6120,14 @@
               <a:spcAft>
                 <a:spcPts val="800"/>
               </a:spcAft>
-              <a:defRPr sz="1200">
+              <a:defRPr sz="1100">
                 <a:solidFill>
                   <a:srgbClr val="1E293B"/>
                 </a:solidFill>
               </a:defRPr>
             </a:pPr>
             <a:r>
-              <a:t>- Goal: Build a robust ML model that accurately predicts delivery times from operational and environmental attributes.</a:t>
+              <a:t>- Operational Transparency: Communicating confidence windows (+/- margin of error) mitigates delivery frustration.</a:t>
             </a:r>
           </a:p>
         </p:txBody>
@@ -5992,8 +6140,8 @@
         </p:nvSpPr>
         <p:spPr>
           <a:xfrm>
-            <a:off x="4425696" y="1645920"/>
-            <a:ext cx="3328416" cy="4572000"/>
+            <a:off x="4425696" y="1463040"/>
+            <a:ext cx="3328416" cy="4846320"/>
           </a:xfrm>
           <a:prstGeom prst="rect">
             <a:avLst/>
@@ -6037,8 +6185,8 @@
         </p:nvSpPr>
         <p:spPr>
           <a:xfrm>
-            <a:off x="4608576" y="1828800"/>
-            <a:ext cx="2962656" cy="4206240"/>
+            <a:off x="4608576" y="1645920"/>
+            <a:ext cx="2962656" cy="4480560"/>
           </a:xfrm>
           <a:prstGeom prst="rect">
             <a:avLst/>
@@ -6070,14 +6218,14 @@
               <a:spcAft>
                 <a:spcPts val="800"/>
               </a:spcAft>
-              <a:defRPr sz="1200">
+              <a:defRPr sz="1100">
                 <a:solidFill>
                   <a:srgbClr val="1E293B"/>
                 </a:solidFill>
               </a:defRPr>
             </a:pPr>
             <a:r>
-              <a:t>- Conduct thorough Exploratory Data Analysis (EDA) on delivery records.</a:t>
+              <a:t>- Feature Engineering: Preprocess continuous kinematics and encode categorical multi-class features.</a:t>
             </a:r>
           </a:p>
           <a:p>
@@ -6085,14 +6233,14 @@
               <a:spcAft>
                 <a:spcPts val="800"/>
               </a:spcAft>
-              <a:defRPr sz="1200">
+              <a:defRPr sz="1100">
                 <a:solidFill>
                   <a:srgbClr val="1E293B"/>
                 </a:solidFill>
               </a:defRPr>
             </a:pPr>
             <a:r>
-              <a:t>- Handle real-world missing values in weather and traffic conditions.</a:t>
+              <a:t>- Outlier Mitigation: Detect severe delay spikes using IQR fences and apply Winsorization.</a:t>
             </a:r>
           </a:p>
           <a:p>
@@ -6100,14 +6248,14 @@
               <a:spcAft>
                 <a:spcPts val="800"/>
               </a:spcAft>
-              <a:defRPr sz="1200">
+              <a:defRPr sz="1100">
                 <a:solidFill>
                   <a:srgbClr val="1E293B"/>
                 </a:solidFill>
               </a:defRPr>
             </a:pPr>
             <a:r>
-              <a:t>- Detect and treat severe outlier delays using Interquartile Range (IQR).</a:t>
+              <a:t>- Algorithm Benchmark: Develop, evaluate, and tune 5 regression algorithms using 5-fold cross-validation.</a:t>
             </a:r>
           </a:p>
           <a:p>
@@ -6115,29 +6263,14 @@
               <a:spcAft>
                 <a:spcPts val="800"/>
               </a:spcAft>
-              <a:defRPr sz="1200">
+              <a:defRPr sz="1100">
                 <a:solidFill>
                   <a:srgbClr val="1E293B"/>
                 </a:solidFill>
               </a:defRPr>
             </a:pPr>
             <a:r>
-              <a:t>- Develop, tune, and evaluate 5 distinct regression algorithms.</a:t>
-            </a:r>
-          </a:p>
-          <a:p>
-            <a:pPr>
-              <a:spcAft>
-                <a:spcPts val="800"/>
-              </a:spcAft>
-              <a:defRPr sz="1200">
-                <a:solidFill>
-                  <a:srgbClr val="1E293B"/>
-                </a:solidFill>
-              </a:defRPr>
-            </a:pPr>
-            <a:r>
-              <a:t>- Perform 5-Fold Cross-Validation to guarantee model generalization.</a:t>
+              <a:t>- Metric Analysis: Rigorously analyze why MAE is superior to RMSE under delay shocks.</a:t>
             </a:r>
           </a:p>
         </p:txBody>
@@ -6150,8 +6283,8 @@
         </p:nvSpPr>
         <p:spPr>
           <a:xfrm>
-            <a:off x="8119872" y="1645920"/>
-            <a:ext cx="3328416" cy="4572000"/>
+            <a:off x="8119872" y="1463040"/>
+            <a:ext cx="3328416" cy="4846320"/>
           </a:xfrm>
           <a:prstGeom prst="rect">
             <a:avLst/>
@@ -6195,8 +6328,8 @@
         </p:nvSpPr>
         <p:spPr>
           <a:xfrm>
-            <a:off x="8302752" y="1828800"/>
-            <a:ext cx="2962656" cy="4206240"/>
+            <a:off x="8302752" y="1645920"/>
+            <a:ext cx="2962656" cy="4480560"/>
           </a:xfrm>
           <a:prstGeom prst="rect">
             <a:avLst/>
@@ -6220,7 +6353,7 @@
               </a:defRPr>
             </a:pPr>
             <a:r>
-              <a:t>Required Deliverables</a:t>
+              <a:t>Production Deliverables</a:t>
             </a:r>
           </a:p>
           <a:p>
@@ -6228,14 +6361,14 @@
               <a:spcAft>
                 <a:spcPts val="800"/>
               </a:spcAft>
-              <a:defRPr sz="1200">
+              <a:defRPr sz="1100">
                 <a:solidFill>
                   <a:srgbClr val="1E293B"/>
                 </a:solidFill>
               </a:defRPr>
             </a:pPr>
             <a:r>
-              <a:t>- Model Benchmark: Compare R2, MSE, RMSE, and MAE across all models.</a:t>
+              <a:t>- Jupyter Notebook: Pre-rendered, unhardcoded notebook covering all stages of the ML lifecycle.</a:t>
             </a:r>
           </a:p>
           <a:p>
@@ -6243,14 +6376,14 @@
               <a:spcAft>
                 <a:spcPts val="800"/>
               </a:spcAft>
-              <a:defRPr sz="1200">
+              <a:defRPr sz="1100">
                 <a:solidFill>
                   <a:srgbClr val="1E293B"/>
                 </a:solidFill>
               </a:defRPr>
             </a:pPr>
             <a:r>
-              <a:t>- MAE vs RMSE Study: Explain why MAE is superior under outlier delay shocks.</a:t>
+              <a:t>- Serialized Model Pipeline: Production-ready Scikit-Learn artifact containing model, scaler, and metadata.</a:t>
             </a:r>
           </a:p>
           <a:p>
@@ -6258,29 +6391,14 @@
               <a:spcAft>
                 <a:spcPts val="800"/>
               </a:spcAft>
-              <a:defRPr sz="1200">
+              <a:defRPr sz="1100">
                 <a:solidFill>
                   <a:srgbClr val="1E293B"/>
                 </a:solidFill>
               </a:defRPr>
             </a:pPr>
             <a:r>
-              <a:t>- Residual Analysis: Validate homoscedasticity and zero-mean error distribution.</a:t>
-            </a:r>
-          </a:p>
-          <a:p>
-            <a:pPr>
-              <a:spcAft>
-                <a:spcPts val="800"/>
-              </a:spcAft>
-              <a:defRPr sz="1200">
-                <a:solidFill>
-                  <a:srgbClr val="1E293B"/>
-                </a:solidFill>
-              </a:defRPr>
-            </a:pPr>
-            <a:r>
-              <a:t>- Interactive Web App: Deploy trained pipeline with user input controls and ETA confidence windows.</a:t>
+              <a:t>- Interactive Web App: Clean, responsive Streamlit dashboard with parameter sliders and priority dispatch toggle.</a:t>
             </a:r>
           </a:p>
         </p:txBody>
@@ -6311,7 +6429,7 @@
         </p:nvSpPr>
         <p:spPr>
           <a:xfrm>
-            <a:off x="731520" y="365760"/>
+            <a:off x="731520" y="320040"/>
             <a:ext cx="10698480" cy="1005840"/>
           </a:xfrm>
           <a:prstGeom prst="rect">
@@ -6327,7 +6445,7 @@
           <a:p>
             <a:pPr>
               <a:spcAft>
-                <a:spcPts val="400"/>
+                <a:spcPts val="200"/>
               </a:spcAft>
               <a:defRPr sz="1000" b="1">
                 <a:solidFill>
@@ -6342,7 +6460,7 @@
           </a:p>
           <a:p>
             <a:pPr>
-              <a:defRPr sz="2200" b="1">
+              <a:defRPr sz="2100" b="1">
                 <a:solidFill>
                   <a:srgbClr val="0F172A"/>
                 </a:solidFill>
@@ -6350,7 +6468,7 @@
               </a:defRPr>
             </a:pPr>
             <a:r>
-              <a:t>Dataset Architecture &amp; Feature Engineering Specifications</a:t>
+              <a:t>Dataset Architecture &amp; Feature Definitions</a:t>
             </a:r>
           </a:p>
         </p:txBody>
@@ -6364,8 +6482,8 @@
           <p:nvPr/>
         </p:nvGraphicFramePr>
         <p:xfrm>
-          <a:off x="731520" y="1645920"/>
-          <a:ext cx="6400800" cy="4572000"/>
+          <a:off x="731520" y="1463040"/>
+          <a:ext cx="6400800" cy="4846320"/>
         </p:xfrm>
         <a:graphic>
           <a:graphicData uri="http://schemas.openxmlformats.org/drawingml/2006/table">
@@ -6375,10 +6493,10 @@
               </a:tblPr>
               <a:tblGrid>
                 <a:gridCol w="2011680"/>
-                <a:gridCol w="1463040"/>
-                <a:gridCol w="2926080"/>
+                <a:gridCol w="1371600"/>
+                <a:gridCol w="3017520"/>
               </a:tblGrid>
-              <a:tr h="571500">
+              <a:tr h="605790">
                 <a:tc>
                   <a:txBody>
                     <a:bodyPr/>
@@ -6449,7 +6567,7 @@
                   </a:tcPr>
                 </a:tc>
               </a:tr>
-              <a:tr h="571500">
+              <a:tr h="605790">
                 <a:tc>
                   <a:txBody>
                     <a:bodyPr/>
@@ -6509,7 +6627,7 @@
                         </a:defRPr>
                       </a:pPr>
                       <a:r>
-                        <a:t>Trip distance between restaurant &amp; customer (1-25 km)</a:t>
+                        <a:t>Haversine/Road trip distance (1.0 to 25.0 km)</a:t>
                       </a:r>
                     </a:p>
                   </a:txBody>
@@ -6520,7 +6638,7 @@
                   </a:tcPr>
                 </a:tc>
               </a:tr>
-              <a:tr h="571500">
+              <a:tr h="605790">
                 <a:tc>
                   <a:txBody>
                     <a:bodyPr/>
@@ -6580,7 +6698,7 @@
                         </a:defRPr>
                       </a:pPr>
                       <a:r>
-                        <a:t>Kitchen preparation and packaging time (8-45 min)</a:t>
+                        <a:t>Kitchen preparation and packaging duration (8 to 45 min)</a:t>
                       </a:r>
                     </a:p>
                   </a:txBody>
@@ -6591,7 +6709,7 @@
                   </a:tcPr>
                 </a:tc>
               </a:tr>
-              <a:tr h="571500">
+              <a:tr h="605790">
                 <a:tc>
                   <a:txBody>
                     <a:bodyPr/>
@@ -6628,7 +6746,7 @@
                         </a:defRPr>
                       </a:pPr>
                       <a:r>
-                        <a:t>Categorical</a:t>
+                        <a:t>Categorical (4 levels)</a:t>
                       </a:r>
                     </a:p>
                   </a:txBody>
@@ -6651,7 +6769,7 @@
                         </a:defRPr>
                       </a:pPr>
                       <a:r>
-                        <a:t>Road condition: Low, Medium, High, Jam</a:t>
+                        <a:t>Congestion state: Low, Medium, High, Jam</a:t>
                       </a:r>
                     </a:p>
                   </a:txBody>
@@ -6662,7 +6780,7 @@
                   </a:tcPr>
                 </a:tc>
               </a:tr>
-              <a:tr h="571500">
+              <a:tr h="605790">
                 <a:tc>
                   <a:txBody>
                     <a:bodyPr/>
@@ -6699,7 +6817,7 @@
                         </a:defRPr>
                       </a:pPr>
                       <a:r>
-                        <a:t>Categorical</a:t>
+                        <a:t>Categorical (6 levels)</a:t>
                       </a:r>
                     </a:p>
                   </a:txBody>
@@ -6722,7 +6840,7 @@
                         </a:defRPr>
                       </a:pPr>
                       <a:r>
-                        <a:t>Environmental state: Clear, Sunny, Rainy, Stormy, etc.</a:t>
+                        <a:t>Weather state: Clear, Sunny, Cloudy, Foggy, Rainy, Stormy</a:t>
                       </a:r>
                     </a:p>
                   </a:txBody>
@@ -6733,7 +6851,7 @@
                   </a:tcPr>
                 </a:tc>
               </a:tr>
-              <a:tr h="571500">
+              <a:tr h="605790">
                 <a:tc>
                   <a:txBody>
                     <a:bodyPr/>
@@ -6770,7 +6888,7 @@
                         </a:defRPr>
                       </a:pPr>
                       <a:r>
-                        <a:t>Categorical</a:t>
+                        <a:t>Categorical (4 levels)</a:t>
                       </a:r>
                     </a:p>
                   </a:txBody>
@@ -6793,7 +6911,7 @@
                         </a:defRPr>
                       </a:pPr>
                       <a:r>
-                        <a:t>Order placement window: Morning, Afternoon, Evening, Night</a:t>
+                        <a:t>Order timestamp window: Morning, Afternoon, Evening, Night</a:t>
                       </a:r>
                     </a:p>
                   </a:txBody>
@@ -6804,7 +6922,7 @@
                   </a:tcPr>
                 </a:tc>
               </a:tr>
-              <a:tr h="571500">
+              <a:tr h="605790">
                 <a:tc>
                   <a:txBody>
                     <a:bodyPr/>
@@ -6875,7 +6993,7 @@
                   </a:tcPr>
                 </a:tc>
               </a:tr>
-              <a:tr h="571500">
+              <a:tr h="605790">
                 <a:tc>
                   <a:txBody>
                     <a:bodyPr/>
@@ -6935,7 +7053,7 @@
                         </a:defRPr>
                       </a:pPr>
                       <a:r>
-                        <a:t>Total duration from order creation to customer receipt</a:t>
+                        <a:t>Total elapsed order duration in minutes (Target Variable)</a:t>
                       </a:r>
                     </a:p>
                   </a:txBody>
@@ -6958,8 +7076,8 @@
         </p:nvSpPr>
         <p:spPr>
           <a:xfrm>
-            <a:off x="7406640" y="1645920"/>
-            <a:ext cx="4023360" cy="4572000"/>
+            <a:off x="7406640" y="1463040"/>
+            <a:ext cx="4023360" cy="4846320"/>
           </a:xfrm>
           <a:prstGeom prst="rect">
             <a:avLst/>
@@ -7003,8 +7121,8 @@
         </p:nvSpPr>
         <p:spPr>
           <a:xfrm>
-            <a:off x="7589520" y="1828800"/>
-            <a:ext cx="3657600" cy="4206240"/>
+            <a:off x="7589520" y="1645920"/>
+            <a:ext cx="3657600" cy="4480560"/>
           </a:xfrm>
           <a:prstGeom prst="rect">
             <a:avLst/>
@@ -7043,7 +7161,7 @@
               </a:defRPr>
             </a:pPr>
             <a:r>
-              <a:t>- Sample Size: 5,000 historical order records generated deterministically based on real-world kinematics.</a:t>
+              <a:t>- Volume: 5,000 historical order records based on physical traffic and velocity equations.</a:t>
             </a:r>
           </a:p>
           <a:p>
@@ -7058,7 +7176,7 @@
               </a:defRPr>
             </a:pPr>
             <a:r>
-              <a:t>- Kinematic Modeling: Transit duration modeled by distance divided by traffic speed (Jam: 9 km/h, Low: 32 km/h).</a:t>
+              <a:t>- Velocity Modeling: Traffic speeds mapped realistically (Low: 32 km/h, Med: 24 km/h, High: 16 km/h, Jam: 9 km/h).</a:t>
             </a:r>
           </a:p>
           <a:p>
@@ -7073,7 +7191,7 @@
               </a:defRPr>
             </a:pPr>
             <a:r>
-              <a:t>- Weather Friction: Additive penalties applied for adverse conditions (Stormy: +14m, Rainy: +7m).</a:t>
+              <a:t>- Environmental Friction: Weather conditions introduce systematic road friction (Rain: +7m, Storm: +14m).</a:t>
             </a:r>
           </a:p>
           <a:p>
@@ -7088,7 +7206,7 @@
               </a:defRPr>
             </a:pPr>
             <a:r>
-              <a:t>- Missing Value Injection: 4% realistic missing data injected into traffic and weather fields to test imputation logic.</a:t>
+              <a:t>- Missing Data: Injected ~4% missing values into traffic and weather fields to test dynamic imputation.</a:t>
             </a:r>
           </a:p>
           <a:p>
@@ -7103,7 +7221,7 @@
               </a:defRPr>
             </a:pPr>
             <a:r>
-              <a:t>- Delay Outliers: ~3.5% isolated breakdown events (35-75 min delay) injected to test metric robustness.</a:t>
+              <a:t>- Extreme Delays: Injected ~3.5% isolated breakdown delays (35-75m) to evaluate model outlier resilience.</a:t>
             </a:r>
           </a:p>
         </p:txBody>
@@ -7134,7 +7252,7 @@
         </p:nvSpPr>
         <p:spPr>
           <a:xfrm>
-            <a:off x="731520" y="365760"/>
+            <a:off x="731520" y="320040"/>
             <a:ext cx="10698480" cy="1005840"/>
           </a:xfrm>
           <a:prstGeom prst="rect">
@@ -7150,7 +7268,7 @@
           <a:p>
             <a:pPr>
               <a:spcAft>
-                <a:spcPts val="400"/>
+                <a:spcPts val="200"/>
               </a:spcAft>
               <a:defRPr sz="1000" b="1">
                 <a:solidFill>
@@ -7165,7 +7283,7 @@
           </a:p>
           <a:p>
             <a:pPr>
-              <a:defRPr sz="2200" b="1">
+              <a:defRPr sz="2100" b="1">
                 <a:solidFill>
                   <a:srgbClr val="0F172A"/>
                 </a:solidFill>
@@ -7173,14 +7291,14 @@
               </a:defRPr>
             </a:pPr>
             <a:r>
-              <a:t>Data Cleaning: Imputation &amp; IQR Outlier Capping</a:t>
+              <a:t>Target Distribution &amp; Outlier Treatment (IQR Method)</a:t>
             </a:r>
           </a:p>
         </p:txBody>
       </p:sp>
       <p:pic>
         <p:nvPicPr>
-          <p:cNvPr id="3" name="Picture 2" descr="1_target_and_outliers.png"/>
+          <p:cNvPr id="3" name="Picture 2" descr="1_raw_distribution.png"/>
           <p:cNvPicPr>
             <a:picLocks noChangeAspect="1"/>
           </p:cNvPicPr>
@@ -7194,8 +7312,8 @@
         </p:blipFill>
         <p:spPr>
           <a:xfrm>
-            <a:off x="731520" y="1645920"/>
-            <a:ext cx="6217920" cy="2763520"/>
+            <a:off x="731520" y="1417320"/>
+            <a:ext cx="5120640" cy="3435330"/>
           </a:xfrm>
           <a:prstGeom prst="rect">
             <a:avLst/>
@@ -7210,8 +7328,8 @@
         </p:nvSpPr>
         <p:spPr>
           <a:xfrm>
-            <a:off x="7132320" y="1645920"/>
-            <a:ext cx="4297680" cy="4572000"/>
+            <a:off x="731520" y="4709160"/>
+            <a:ext cx="5120640" cy="1828800"/>
           </a:xfrm>
           <a:prstGeom prst="rect">
             <a:avLst/>
@@ -7255,8 +7373,8 @@
         </p:nvSpPr>
         <p:spPr>
           <a:xfrm>
-            <a:off x="7315200" y="1828800"/>
-            <a:ext cx="3931920" cy="4206240"/>
+            <a:off x="914400" y="4818888"/>
+            <a:ext cx="4754880" cy="1609344"/>
           </a:xfrm>
           <a:prstGeom prst="rect">
             <a:avLst/>
@@ -7271,106 +7389,213 @@
           <a:p>
             <a:pPr>
               <a:spcAft>
-                <a:spcPts val="1000"/>
-              </a:spcAft>
-              <a:defRPr sz="1600" b="1">
+                <a:spcPts val="400"/>
+              </a:spcAft>
+              <a:defRPr sz="1200" b="1">
                 <a:solidFill>
                   <a:srgbClr val="0F172A"/>
                 </a:solidFill>
               </a:defRPr>
             </a:pPr>
             <a:r>
-              <a:t>Outlier Handling Methodology</a:t>
-            </a:r>
-          </a:p>
-          <a:p>
-            <a:pPr>
-              <a:spcAft>
-                <a:spcPts val="600"/>
-              </a:spcAft>
-              <a:defRPr sz="1100">
+              <a:t>Graph 1: Raw Delivery Time Distribution</a:t>
+            </a:r>
+          </a:p>
+          <a:p>
+            <a:pPr>
+              <a:spcAft>
+                <a:spcPts val="300"/>
+              </a:spcAft>
+              <a:defRPr sz="1000">
                 <a:solidFill>
                   <a:srgbClr val="1E293B"/>
                 </a:solidFill>
               </a:defRPr>
             </a:pPr>
             <a:r>
-              <a:t>- Dynamic Imputation: Missing values in categorical columns (traffic &amp; weather) filled with column mode; numerical columns filled with median.</a:t>
-            </a:r>
-          </a:p>
-          <a:p>
-            <a:pPr>
-              <a:spcAft>
-                <a:spcPts val="600"/>
-              </a:spcAft>
-              <a:defRPr sz="1100">
+              <a:t>- Target Skewness: The raw distribution exhibits positive right skew (median = 43.2 min, max = 180 min).</a:t>
+            </a:r>
+          </a:p>
+          <a:p>
+            <a:pPr>
+              <a:spcAft>
+                <a:spcPts val="300"/>
+              </a:spcAft>
+              <a:defRPr sz="1000">
                 <a:solidFill>
                   <a:srgbClr val="1E293B"/>
                 </a:solidFill>
               </a:defRPr>
             </a:pPr>
             <a:r>
-              <a:t>- Right-Skewed Distribution: Raw delivery time has positive skew (median = 43.2 min, max = 180 min) due to severe delays.</a:t>
-            </a:r>
-          </a:p>
-          <a:p>
-            <a:pPr>
-              <a:spcAft>
-                <a:spcPts val="600"/>
-              </a:spcAft>
-              <a:defRPr sz="1100">
+              <a:t>- Outlier Causes: Prolonged orders are caused by rare breakdown events (flat tires, kitchen failure, road blocks).</a:t>
+            </a:r>
+          </a:p>
+          <a:p>
+            <a:pPr>
+              <a:spcAft>
+                <a:spcPts val="300"/>
+              </a:spcAft>
+              <a:defRPr sz="1000">
                 <a:solidFill>
                   <a:srgbClr val="1E293B"/>
                 </a:solidFill>
               </a:defRPr>
             </a:pPr>
             <a:r>
-              <a:t>- IQR Formulation: Q1 = 33.6 min, Q3 = 56.3 min, IQR = 22.7 min.</a:t>
-            </a:r>
-          </a:p>
-          <a:p>
-            <a:pPr>
-              <a:spcAft>
-                <a:spcPts val="600"/>
-              </a:spcAft>
-              <a:defRPr sz="1100">
+              <a:t>- Imputation: Categorical missing fields imputed dynamically with column mode.</a:t>
+            </a:r>
+          </a:p>
+        </p:txBody>
+      </p:sp>
+      <p:pic>
+        <p:nvPicPr>
+          <p:cNvPr id="6" name="Picture 5" descr="2_outlier_treatment_boxplot.png"/>
+          <p:cNvPicPr>
+            <a:picLocks noChangeAspect="1"/>
+          </p:cNvPicPr>
+          <p:nvPr/>
+        </p:nvPicPr>
+        <p:blipFill>
+          <a:blip r:embed="rId3"/>
+          <a:stretch>
+            <a:fillRect/>
+          </a:stretch>
+        </p:blipFill>
+        <p:spPr>
+          <a:xfrm>
+            <a:off x="6309360" y="1417320"/>
+            <a:ext cx="5120640" cy="3437219"/>
+          </a:xfrm>
+          <a:prstGeom prst="rect">
+            <a:avLst/>
+          </a:prstGeom>
+        </p:spPr>
+      </p:pic>
+      <p:sp>
+        <p:nvSpPr>
+          <p:cNvPr id="7" name="Rectangle 6"/>
+          <p:cNvSpPr/>
+          <p:nvPr/>
+        </p:nvSpPr>
+        <p:spPr>
+          <a:xfrm>
+            <a:off x="6309360" y="4709160"/>
+            <a:ext cx="5120640" cy="1828800"/>
+          </a:xfrm>
+          <a:prstGeom prst="rect">
+            <a:avLst/>
+          </a:prstGeom>
+          <a:solidFill>
+            <a:srgbClr val="F8FAFC"/>
+          </a:solidFill>
+          <a:ln w="12700">
+            <a:solidFill>
+              <a:srgbClr val="E2E8F0"/>
+            </a:solidFill>
+          </a:ln>
+        </p:spPr>
+        <p:style>
+          <a:lnRef idx="1">
+            <a:schemeClr val="accent1"/>
+          </a:lnRef>
+          <a:fillRef idx="3">
+            <a:schemeClr val="accent1"/>
+          </a:fillRef>
+          <a:effectRef idx="2">
+            <a:schemeClr val="accent1"/>
+          </a:effectRef>
+          <a:fontRef idx="minor">
+            <a:schemeClr val="lt1"/>
+          </a:fontRef>
+        </p:style>
+        <p:txBody>
+          <a:bodyPr rtlCol="0" anchor="ctr"/>
+          <a:lstStyle/>
+          <a:p>
+            <a:pPr algn="ctr"/>
+          </a:p>
+        </p:txBody>
+      </p:sp>
+      <p:sp>
+        <p:nvSpPr>
+          <p:cNvPr id="8" name="TextBox 7"/>
+          <p:cNvSpPr txBox="1"/>
+          <p:nvPr/>
+        </p:nvSpPr>
+        <p:spPr>
+          <a:xfrm>
+            <a:off x="6492240" y="4818888"/>
+            <a:ext cx="4754880" cy="1609344"/>
+          </a:xfrm>
+          <a:prstGeom prst="rect">
+            <a:avLst/>
+          </a:prstGeom>
+          <a:noFill/>
+        </p:spPr>
+        <p:txBody>
+          <a:bodyPr wrap="square">
+            <a:spAutoFit/>
+          </a:bodyPr>
+          <a:lstStyle/>
+          <a:p>
+            <a:pPr>
+              <a:spcAft>
+                <a:spcPts val="400"/>
+              </a:spcAft>
+              <a:defRPr sz="1200" b="1">
+                <a:solidFill>
+                  <a:srgbClr val="0F172A"/>
+                </a:solidFill>
+              </a:defRPr>
+            </a:pPr>
+            <a:r>
+              <a:t>Graph 2: Outlier Detection &amp; Capping</a:t>
+            </a:r>
+          </a:p>
+          <a:p>
+            <a:pPr>
+              <a:spcAft>
+                <a:spcPts val="300"/>
+              </a:spcAft>
+              <a:defRPr sz="1000">
                 <a:solidFill>
                   <a:srgbClr val="1E293B"/>
                 </a:solidFill>
               </a:defRPr>
             </a:pPr>
             <a:r>
-              <a:t>- Upper Threshold: Q3 + 1.5 * IQR = 75.2 minutes. Orders beyond this threshold are classified as outliers.</a:t>
-            </a:r>
-          </a:p>
-          <a:p>
-            <a:pPr>
-              <a:spcAft>
-                <a:spcPts val="600"/>
-              </a:spcAft>
-              <a:defRPr sz="1100">
+              <a:t>- IQR Threshold: Q1 = 33.6m, Q3 = 56.3m, IQR = 22.7m. Upper fence = Q3 + 1.5*IQR = 75.2 minutes.</a:t>
+            </a:r>
+          </a:p>
+          <a:p>
+            <a:pPr>
+              <a:spcAft>
+                <a:spcPts val="300"/>
+              </a:spcAft>
+              <a:defRPr sz="1000">
                 <a:solidFill>
                   <a:srgbClr val="1E293B"/>
                 </a:solidFill>
               </a:defRPr>
             </a:pPr>
             <a:r>
-              <a:t>- Capping (Winsorization): Extreme outlier delays are clipped to the upper threshold (75 min).</a:t>
-            </a:r>
-          </a:p>
-          <a:p>
-            <a:pPr>
-              <a:spcAft>
-                <a:spcPts val="600"/>
-              </a:spcAft>
-              <a:defRPr sz="1100">
+              <a:t>- Winsorization Treatment: Orders exceeding 75.2m are clipped to the upper boundary.</a:t>
+            </a:r>
+          </a:p>
+          <a:p>
+            <a:pPr>
+              <a:spcAft>
+                <a:spcPts val="300"/>
+              </a:spcAft>
+              <a:defRPr sz="1000">
                 <a:solidFill>
                   <a:srgbClr val="1E293B"/>
                 </a:solidFill>
               </a:defRPr>
             </a:pPr>
             <a:r>
-              <a:t>- Impact: Stabilizes loss gradients and prevents linear models from blowing up while preserving all training samples.</a:t>
+              <a:t>- Mathematical Benefit: Prevents gradient explosion and excessive squared loss distortion during training.</a:t>
             </a:r>
           </a:p>
         </p:txBody>
@@ -7401,7 +7626,7 @@
         </p:nvSpPr>
         <p:spPr>
           <a:xfrm>
-            <a:off x="731520" y="365760"/>
+            <a:off x="731520" y="320040"/>
             <a:ext cx="10698480" cy="1005840"/>
           </a:xfrm>
           <a:prstGeom prst="rect">
@@ -7417,7 +7642,7 @@
           <a:p>
             <a:pPr>
               <a:spcAft>
-                <a:spcPts val="400"/>
+                <a:spcPts val="200"/>
               </a:spcAft>
               <a:defRPr sz="1000" b="1">
                 <a:solidFill>
@@ -7432,7 +7657,7 @@
           </a:p>
           <a:p>
             <a:pPr>
-              <a:defRPr sz="2200" b="1">
+              <a:defRPr sz="2100" b="1">
                 <a:solidFill>
                   <a:srgbClr val="0F172A"/>
                 </a:solidFill>
@@ -7440,14 +7665,14 @@
               </a:defRPr>
             </a:pPr>
             <a:r>
-              <a:t>Bivariate Analysis: Primary Continuous Determinants</a:t>
+              <a:t>Bivariate Predictor Analysis: Distance &amp; Kitchen Preparation Time</a:t>
             </a:r>
           </a:p>
         </p:txBody>
       </p:sp>
       <p:pic>
         <p:nvPicPr>
-          <p:cNvPr id="3" name="Picture 2" descr="2_bivariate_drivers.png"/>
+          <p:cNvPr id="3" name="Picture 2" descr="3_distance_vs_time.png"/>
           <p:cNvPicPr>
             <a:picLocks noChangeAspect="1"/>
           </p:cNvPicPr>
@@ -7461,8 +7686,8 @@
         </p:blipFill>
         <p:spPr>
           <a:xfrm>
-            <a:off x="731520" y="1554480"/>
-            <a:ext cx="10698480" cy="3403057"/>
+            <a:off x="731520" y="1417320"/>
+            <a:ext cx="5120640" cy="3432517"/>
           </a:xfrm>
           <a:prstGeom prst="rect">
             <a:avLst/>
@@ -7477,8 +7702,8 @@
         </p:nvSpPr>
         <p:spPr>
           <a:xfrm>
-            <a:off x="731520" y="4480560"/>
-            <a:ext cx="3328416" cy="1828800"/>
+            <a:off x="731520" y="4709160"/>
+            <a:ext cx="5120640" cy="1828800"/>
           </a:xfrm>
           <a:prstGeom prst="rect">
             <a:avLst/>
@@ -7522,8 +7747,8 @@
         </p:nvSpPr>
         <p:spPr>
           <a:xfrm>
-            <a:off x="868680" y="4617720"/>
-            <a:ext cx="3054096" cy="1554480"/>
+            <a:off x="914400" y="4818888"/>
+            <a:ext cx="4754880" cy="1609344"/>
           </a:xfrm>
           <a:prstGeom prst="rect">
             <a:avLst/>
@@ -7540,40 +7765,97 @@
               <a:spcAft>
                 <a:spcPts val="400"/>
               </a:spcAft>
-              <a:defRPr sz="1300" b="1">
+              <a:defRPr sz="1200" b="1">
                 <a:solidFill>
                   <a:srgbClr val="0F172A"/>
                 </a:solidFill>
               </a:defRPr>
             </a:pPr>
             <a:r>
-              <a:t>Distance Relationship</a:t>
-            </a:r>
-          </a:p>
-          <a:p>
-            <a:pPr>
-              <a:defRPr sz="1050">
+              <a:t>Graph 3: Distance vs Delivery Time</a:t>
+            </a:r>
+          </a:p>
+          <a:p>
+            <a:pPr>
+              <a:spcAft>
+                <a:spcPts val="300"/>
+              </a:spcAft>
+              <a:defRPr sz="1000">
                 <a:solidFill>
                   <a:srgbClr val="1E293B"/>
                 </a:solidFill>
               </a:defRPr>
             </a:pPr>
             <a:r>
-              <a:t>Distance exhibits a strong direct positive relationship with delivery duration. Travel time increases proportionally with trip kilometers.</a:t>
-            </a:r>
-          </a:p>
-        </p:txBody>
-      </p:sp>
-      <p:sp>
-        <p:nvSpPr>
-          <p:cNvPr id="6" name="Rectangle 5"/>
+              <a:t>- Primary Continuous Driver: Distance exhibits a strong positive relationship with delivery duration.</a:t>
+            </a:r>
+          </a:p>
+          <a:p>
+            <a:pPr>
+              <a:spcAft>
+                <a:spcPts val="300"/>
+              </a:spcAft>
+              <a:defRPr sz="1000">
+                <a:solidFill>
+                  <a:srgbClr val="1E293B"/>
+                </a:solidFill>
+              </a:defRPr>
+            </a:pPr>
+            <a:r>
+              <a:t>- Kinematic Linearity: Travel time increases roughly linearly with distance under free-flow conditions.</a:t>
+            </a:r>
+          </a:p>
+          <a:p>
+            <a:pPr>
+              <a:spcAft>
+                <a:spcPts val="300"/>
+              </a:spcAft>
+              <a:defRPr sz="1000">
+                <a:solidFill>
+                  <a:srgbClr val="1E293B"/>
+                </a:solidFill>
+              </a:defRPr>
+            </a:pPr>
+            <a:r>
+              <a:t>- Scatter Dispersion: Widening vertical dispersion at larger distances reflects compounding traffic drag.</a:t>
+            </a:r>
+          </a:p>
+        </p:txBody>
+      </p:sp>
+      <p:pic>
+        <p:nvPicPr>
+          <p:cNvPr id="6" name="Picture 5" descr="4_prep_vs_time.png"/>
+          <p:cNvPicPr>
+            <a:picLocks noChangeAspect="1"/>
+          </p:cNvPicPr>
+          <p:nvPr/>
+        </p:nvPicPr>
+        <p:blipFill>
+          <a:blip r:embed="rId3"/>
+          <a:stretch>
+            <a:fillRect/>
+          </a:stretch>
+        </p:blipFill>
+        <p:spPr>
+          <a:xfrm>
+            <a:off x="6309360" y="1417320"/>
+            <a:ext cx="5120640" cy="3435330"/>
+          </a:xfrm>
+          <a:prstGeom prst="rect">
+            <a:avLst/>
+          </a:prstGeom>
+        </p:spPr>
+      </p:pic>
+      <p:sp>
+        <p:nvSpPr>
+          <p:cNvPr id="7" name="Rectangle 6"/>
           <p:cNvSpPr/>
           <p:nvPr/>
         </p:nvSpPr>
         <p:spPr>
           <a:xfrm>
-            <a:off x="4425696" y="4480560"/>
-            <a:ext cx="3328416" cy="1828800"/>
+            <a:off x="6309360" y="4709160"/>
+            <a:ext cx="5120640" cy="1828800"/>
           </a:xfrm>
           <a:prstGeom prst="rect">
             <a:avLst/>
@@ -7611,14 +7893,14 @@
       </p:sp>
       <p:sp>
         <p:nvSpPr>
-          <p:cNvPr id="7" name="TextBox 6"/>
+          <p:cNvPr id="8" name="TextBox 7"/>
           <p:cNvSpPr txBox="1"/>
           <p:nvPr/>
         </p:nvSpPr>
         <p:spPr>
           <a:xfrm>
-            <a:off x="4562856" y="4617720"/>
-            <a:ext cx="3054096" cy="1554480"/>
+            <a:off x="6492240" y="4818888"/>
+            <a:ext cx="4754880" cy="1609344"/>
           </a:xfrm>
           <a:prstGeom prst="rect">
             <a:avLst/>
@@ -7635,121 +7917,59 @@
               <a:spcAft>
                 <a:spcPts val="400"/>
               </a:spcAft>
-              <a:defRPr sz="1300" b="1">
+              <a:defRPr sz="1200" b="1">
                 <a:solidFill>
                   <a:srgbClr val="0F172A"/>
                 </a:solidFill>
               </a:defRPr>
             </a:pPr>
             <a:r>
-              <a:t>Kitchen Prep Latency</a:t>
-            </a:r>
-          </a:p>
-          <a:p>
-            <a:pPr>
-              <a:defRPr sz="1050">
+              <a:t>Graph 4: Kitchen Preparation Time vs Delivery Time</a:t>
+            </a:r>
+          </a:p>
+          <a:p>
+            <a:pPr>
+              <a:spcAft>
+                <a:spcPts val="300"/>
+              </a:spcAft>
+              <a:defRPr sz="1000">
                 <a:solidFill>
                   <a:srgbClr val="1E293B"/>
                 </a:solidFill>
               </a:defRPr>
             </a:pPr>
             <a:r>
-              <a:t>Kitchen preparation time serves as a direct baseline additive constant (8 to 45 mins). Order prep occurs before driver dispatch.</a:t>
-            </a:r>
-          </a:p>
-        </p:txBody>
-      </p:sp>
-      <p:sp>
-        <p:nvSpPr>
-          <p:cNvPr id="8" name="Rectangle 7"/>
-          <p:cNvSpPr/>
-          <p:nvPr/>
-        </p:nvSpPr>
-        <p:spPr>
-          <a:xfrm>
-            <a:off x="8119872" y="4480560"/>
-            <a:ext cx="3328416" cy="1828800"/>
-          </a:xfrm>
-          <a:prstGeom prst="rect">
-            <a:avLst/>
-          </a:prstGeom>
-          <a:solidFill>
-            <a:srgbClr val="F8FAFC"/>
-          </a:solidFill>
-          <a:ln w="12700">
-            <a:solidFill>
-              <a:srgbClr val="E2E8F0"/>
-            </a:solidFill>
-          </a:ln>
-        </p:spPr>
-        <p:style>
-          <a:lnRef idx="1">
-            <a:schemeClr val="accent1"/>
-          </a:lnRef>
-          <a:fillRef idx="3">
-            <a:schemeClr val="accent1"/>
-          </a:fillRef>
-          <a:effectRef idx="2">
-            <a:schemeClr val="accent1"/>
-          </a:effectRef>
-          <a:fontRef idx="minor">
-            <a:schemeClr val="lt1"/>
-          </a:fontRef>
-        </p:style>
-        <p:txBody>
-          <a:bodyPr rtlCol="0" anchor="ctr"/>
-          <a:lstStyle/>
-          <a:p>
-            <a:pPr algn="ctr"/>
-          </a:p>
-        </p:txBody>
-      </p:sp>
-      <p:sp>
-        <p:nvSpPr>
-          <p:cNvPr id="9" name="TextBox 8"/>
-          <p:cNvSpPr txBox="1"/>
-          <p:nvPr/>
-        </p:nvSpPr>
-        <p:spPr>
-          <a:xfrm>
-            <a:off x="8257032" y="4617720"/>
-            <a:ext cx="3054096" cy="1554480"/>
-          </a:xfrm>
-          <a:prstGeom prst="rect">
-            <a:avLst/>
-          </a:prstGeom>
-          <a:noFill/>
-        </p:spPr>
-        <p:txBody>
-          <a:bodyPr wrap="square">
-            <a:spAutoFit/>
-          </a:bodyPr>
-          <a:lstStyle/>
-          <a:p>
-            <a:pPr>
-              <a:spcAft>
-                <a:spcPts val="400"/>
-              </a:spcAft>
-              <a:defRPr sz="1300" b="1">
-                <a:solidFill>
-                  <a:srgbClr val="0F172A"/>
-                </a:solidFill>
-              </a:defRPr>
-            </a:pPr>
-            <a:r>
-              <a:t>Partner Rating Influence</a:t>
-            </a:r>
-          </a:p>
-          <a:p>
-            <a:pPr>
-              <a:defRPr sz="1050">
+              <a:t>- Operational Baseline: Kitchen preparation represents a direct additive latency constant before transit.</a:t>
+            </a:r>
+          </a:p>
+          <a:p>
+            <a:pPr>
+              <a:spcAft>
+                <a:spcPts val="300"/>
+              </a:spcAft>
+              <a:defRPr sz="1000">
                 <a:solidFill>
                   <a:srgbClr val="1E293B"/>
                 </a:solidFill>
               </a:defRPr>
             </a:pPr>
             <a:r>
-              <a:t>Delivery partners with higher historical ratings (&gt;4.5 stars) demonstrate marginal efficiency gains through faster pickup and route familiarity.</a:t>
+              <a:t>- Linear Regression Slope: Each additional minute of cooking time translates directly into +1 min of delivery time.</a:t>
+            </a:r>
+          </a:p>
+          <a:p>
+            <a:pPr>
+              <a:spcAft>
+                <a:spcPts val="300"/>
+              </a:spcAft>
+              <a:defRPr sz="1000">
+                <a:solidFill>
+                  <a:srgbClr val="1E293B"/>
+                </a:solidFill>
+              </a:defRPr>
+            </a:pPr>
+            <a:r>
+              <a:t>- Operational Implication: Fast kitchen preparation is vital for maintaining acceptable sub-30 minute ETAs.</a:t>
             </a:r>
           </a:p>
         </p:txBody>
@@ -7780,7 +8000,7 @@
         </p:nvSpPr>
         <p:spPr>
           <a:xfrm>
-            <a:off x="731520" y="365760"/>
+            <a:off x="731520" y="320040"/>
             <a:ext cx="10698480" cy="1005840"/>
           </a:xfrm>
           <a:prstGeom prst="rect">
@@ -7796,7 +8016,7 @@
           <a:p>
             <a:pPr>
               <a:spcAft>
-                <a:spcPts val="400"/>
+                <a:spcPts val="200"/>
               </a:spcAft>
               <a:defRPr sz="1000" b="1">
                 <a:solidFill>
@@ -7811,7 +8031,7 @@
           </a:p>
           <a:p>
             <a:pPr>
-              <a:defRPr sz="2200" b="1">
+              <a:defRPr sz="2100" b="1">
                 <a:solidFill>
                   <a:srgbClr val="0F172A"/>
                 </a:solidFill>
@@ -7819,14 +8039,14 @@
               </a:defRPr>
             </a:pPr>
             <a:r>
-              <a:t>Environmental Friction: Traffic Congestion &amp; Weather Impact</a:t>
+              <a:t>Environmental Factors: Traffic Congestion &amp; Weather Conditions</a:t>
             </a:r>
           </a:p>
         </p:txBody>
       </p:sp>
       <p:pic>
         <p:nvPicPr>
-          <p:cNvPr id="3" name="Picture 2" descr="3_environmental_factors.png"/>
+          <p:cNvPr id="3" name="Picture 2" descr="5_traffic_boxplot.png"/>
           <p:cNvPicPr>
             <a:picLocks noChangeAspect="1"/>
           </p:cNvPicPr>
@@ -7840,8 +8060,8 @@
         </p:blipFill>
         <p:spPr>
           <a:xfrm>
-            <a:off x="731520" y="1645920"/>
-            <a:ext cx="6583680" cy="2655619"/>
+            <a:off x="731520" y="1417320"/>
+            <a:ext cx="5120640" cy="3438144"/>
           </a:xfrm>
           <a:prstGeom prst="rect">
             <a:avLst/>
@@ -7856,8 +8076,8 @@
         </p:nvSpPr>
         <p:spPr>
           <a:xfrm>
-            <a:off x="7498079" y="1645920"/>
-            <a:ext cx="3931920" cy="4572000"/>
+            <a:off x="731520" y="4709160"/>
+            <a:ext cx="5120640" cy="1828800"/>
           </a:xfrm>
           <a:prstGeom prst="rect">
             <a:avLst/>
@@ -7901,8 +8121,8 @@
         </p:nvSpPr>
         <p:spPr>
           <a:xfrm>
-            <a:off x="7680960" y="1828800"/>
-            <a:ext cx="3566160" cy="4206240"/>
+            <a:off x="914400" y="4818888"/>
+            <a:ext cx="4754880" cy="1609344"/>
           </a:xfrm>
           <a:prstGeom prst="rect">
             <a:avLst/>
@@ -7917,76 +8137,213 @@
           <a:p>
             <a:pPr>
               <a:spcAft>
-                <a:spcPts val="1200"/>
-              </a:spcAft>
-              <a:defRPr sz="1600" b="1">
+                <a:spcPts val="400"/>
+              </a:spcAft>
+              <a:defRPr sz="1200" b="1">
                 <a:solidFill>
                   <a:srgbClr val="0F172A"/>
                 </a:solidFill>
               </a:defRPr>
             </a:pPr>
             <a:r>
-              <a:t>Operational Insights</a:t>
-            </a:r>
-          </a:p>
-          <a:p>
-            <a:pPr>
-              <a:spcAft>
-                <a:spcPts val="800"/>
-              </a:spcAft>
-              <a:defRPr sz="1100">
+              <a:t>Graph 5: Traffic Density Impact</a:t>
+            </a:r>
+          </a:p>
+          <a:p>
+            <a:pPr>
+              <a:spcAft>
+                <a:spcPts val="300"/>
+              </a:spcAft>
+              <a:defRPr sz="1000">
                 <a:solidFill>
                   <a:srgbClr val="1E293B"/>
                 </a:solidFill>
               </a:defRPr>
             </a:pPr>
             <a:r>
-              <a:t>- Traffic Non-Linearity: Moving from Low to Jam conditions more than doubles median transit time.</a:t>
-            </a:r>
-          </a:p>
-          <a:p>
-            <a:pPr>
-              <a:spcAft>
-                <a:spcPts val="800"/>
-              </a:spcAft>
-              <a:defRPr sz="1100">
+              <a:t>- Non-Linear Traffic Surge: Median delivery time increases from 34 min in 'Low' traffic to 64 min in 'Jam' traffic.</a:t>
+            </a:r>
+          </a:p>
+          <a:p>
+            <a:pPr>
+              <a:spcAft>
+                <a:spcPts val="300"/>
+              </a:spcAft>
+              <a:defRPr sz="1000">
                 <a:solidFill>
                   <a:srgbClr val="1E293B"/>
                 </a:solidFill>
               </a:defRPr>
             </a:pPr>
             <a:r>
-              <a:t>- Jam Density Penalty: Median delivery time climbs from 34 mins in Low traffic to over 64 mins during Jam conditions.</a:t>
-            </a:r>
-          </a:p>
-          <a:p>
-            <a:pPr>
-              <a:spcAft>
-                <a:spcPts val="800"/>
-              </a:spcAft>
-              <a:defRPr sz="1100">
+              <a:t>- Velocity Reduction: Average courier speed drops from 32 km/h in Low density to ~9 km/h during gridlock.</a:t>
+            </a:r>
+          </a:p>
+          <a:p>
+            <a:pPr>
+              <a:spcAft>
+                <a:spcPts val="300"/>
+              </a:spcAft>
+              <a:defRPr sz="1000">
                 <a:solidFill>
                   <a:srgbClr val="1E293B"/>
                 </a:solidFill>
               </a:defRPr>
             </a:pPr>
             <a:r>
-              <a:t>- Weather Delay Multiplier: Stormy and Rainy weather severely restrict courier mobility, shifting distributions rightward.</a:t>
-            </a:r>
-          </a:p>
-          <a:p>
-            <a:pPr>
-              <a:spcAft>
-                <a:spcPts val="800"/>
-              </a:spcAft>
-              <a:defRPr sz="1100">
+              <a:t>- Variance Spread: 'Jam' conditions display the widest interquartile range, reflecting unpredictable transit.</a:t>
+            </a:r>
+          </a:p>
+        </p:txBody>
+      </p:sp>
+      <p:pic>
+        <p:nvPicPr>
+          <p:cNvPr id="6" name="Picture 5" descr="6_weather_boxplot.png"/>
+          <p:cNvPicPr>
+            <a:picLocks noChangeAspect="1"/>
+          </p:cNvPicPr>
+          <p:nvPr/>
+        </p:nvPicPr>
+        <p:blipFill>
+          <a:blip r:embed="rId3"/>
+          <a:stretch>
+            <a:fillRect/>
+          </a:stretch>
+        </p:blipFill>
+        <p:spPr>
+          <a:xfrm>
+            <a:off x="6309360" y="1417320"/>
+            <a:ext cx="5120640" cy="3435330"/>
+          </a:xfrm>
+          <a:prstGeom prst="rect">
+            <a:avLst/>
+          </a:prstGeom>
+        </p:spPr>
+      </p:pic>
+      <p:sp>
+        <p:nvSpPr>
+          <p:cNvPr id="7" name="Rectangle 6"/>
+          <p:cNvSpPr/>
+          <p:nvPr/>
+        </p:nvSpPr>
+        <p:spPr>
+          <a:xfrm>
+            <a:off x="6309360" y="4709160"/>
+            <a:ext cx="5120640" cy="1828800"/>
+          </a:xfrm>
+          <a:prstGeom prst="rect">
+            <a:avLst/>
+          </a:prstGeom>
+          <a:solidFill>
+            <a:srgbClr val="F8FAFC"/>
+          </a:solidFill>
+          <a:ln w="12700">
+            <a:solidFill>
+              <a:srgbClr val="E2E8F0"/>
+            </a:solidFill>
+          </a:ln>
+        </p:spPr>
+        <p:style>
+          <a:lnRef idx="1">
+            <a:schemeClr val="accent1"/>
+          </a:lnRef>
+          <a:fillRef idx="3">
+            <a:schemeClr val="accent1"/>
+          </a:fillRef>
+          <a:effectRef idx="2">
+            <a:schemeClr val="accent1"/>
+          </a:effectRef>
+          <a:fontRef idx="minor">
+            <a:schemeClr val="lt1"/>
+          </a:fontRef>
+        </p:style>
+        <p:txBody>
+          <a:bodyPr rtlCol="0" anchor="ctr"/>
+          <a:lstStyle/>
+          <a:p>
+            <a:pPr algn="ctr"/>
+          </a:p>
+        </p:txBody>
+      </p:sp>
+      <p:sp>
+        <p:nvSpPr>
+          <p:cNvPr id="8" name="TextBox 7"/>
+          <p:cNvSpPr txBox="1"/>
+          <p:nvPr/>
+        </p:nvSpPr>
+        <p:spPr>
+          <a:xfrm>
+            <a:off x="6492240" y="4818888"/>
+            <a:ext cx="4754880" cy="1609344"/>
+          </a:xfrm>
+          <a:prstGeom prst="rect">
+            <a:avLst/>
+          </a:prstGeom>
+          <a:noFill/>
+        </p:spPr>
+        <p:txBody>
+          <a:bodyPr wrap="square">
+            <a:spAutoFit/>
+          </a:bodyPr>
+          <a:lstStyle/>
+          <a:p>
+            <a:pPr>
+              <a:spcAft>
+                <a:spcPts val="400"/>
+              </a:spcAft>
+              <a:defRPr sz="1200" b="1">
+                <a:solidFill>
+                  <a:srgbClr val="0F172A"/>
+                </a:solidFill>
+              </a:defRPr>
+            </a:pPr>
+            <a:r>
+              <a:t>Graph 6: Weather Condition Impact</a:t>
+            </a:r>
+          </a:p>
+          <a:p>
+            <a:pPr>
+              <a:spcAft>
+                <a:spcPts val="300"/>
+              </a:spcAft>
+              <a:defRPr sz="1000">
                 <a:solidFill>
                   <a:srgbClr val="1E293B"/>
                 </a:solidFill>
               </a:defRPr>
             </a:pPr>
             <a:r>
-              <a:t>- Hazard Compounding: The combination of Peak Traffic and Stormy weather produces severe compounding delays that simple linear models struggle to capture without interaction terms.</a:t>
+              <a:t>- Weather Hazard Penalty: Clear and Sunny conditions offer baseline speeds; Stormy weather adds +14 min median delay.</a:t>
+            </a:r>
+          </a:p>
+          <a:p>
+            <a:pPr>
+              <a:spcAft>
+                <a:spcPts val="300"/>
+              </a:spcAft>
+              <a:defRPr sz="1000">
+                <a:solidFill>
+                  <a:srgbClr val="1E293B"/>
+                </a:solidFill>
+              </a:defRPr>
+            </a:pPr>
+            <a:r>
+              <a:t>- Precipitation Friction: Rain and Fog degrade road traction and driver visibility, shifting ETAs rightward.</a:t>
+            </a:r>
+          </a:p>
+          <a:p>
+            <a:pPr>
+              <a:spcAft>
+                <a:spcPts val="300"/>
+              </a:spcAft>
+              <a:defRPr sz="1000">
+                <a:solidFill>
+                  <a:srgbClr val="1E293B"/>
+                </a:solidFill>
+              </a:defRPr>
+            </a:pPr>
+            <a:r>
+              <a:t>- Interaction Effect: Adverse weather combined with peak traffic produces the most severe delay compounding.</a:t>
             </a:r>
           </a:p>
         </p:txBody>
@@ -8017,7 +8374,7 @@
         </p:nvSpPr>
         <p:spPr>
           <a:xfrm>
-            <a:off x="731520" y="365760"/>
+            <a:off x="731520" y="320040"/>
             <a:ext cx="10698480" cy="1005840"/>
           </a:xfrm>
           <a:prstGeom prst="rect">
@@ -8033,7 +8390,7 @@
           <a:p>
             <a:pPr>
               <a:spcAft>
-                <a:spcPts val="400"/>
+                <a:spcPts val="200"/>
               </a:spcAft>
               <a:defRPr sz="1000" b="1">
                 <a:solidFill>
@@ -8048,7 +8405,7 @@
           </a:p>
           <a:p>
             <a:pPr>
-              <a:defRPr sz="2200" b="1">
+              <a:defRPr sz="2100" b="1">
                 <a:solidFill>
                   <a:srgbClr val="0F172A"/>
                 </a:solidFill>
@@ -8056,14 +8413,14 @@
               </a:defRPr>
             </a:pPr>
             <a:r>
-              <a:t>Correlation Analysis &amp; Multicollinearity Diagnostics</a:t>
+              <a:t>Multicollinearity Diagnostics &amp; Partner Rating Impact</a:t>
             </a:r>
           </a:p>
         </p:txBody>
       </p:sp>
       <p:pic>
         <p:nvPicPr>
-          <p:cNvPr id="3" name="Picture 2" descr="4_correlation_heatmap.png"/>
+          <p:cNvPr id="3" name="Picture 2" descr="7_correlation_heatmap.png"/>
           <p:cNvPicPr>
             <a:picLocks noChangeAspect="1"/>
           </p:cNvPicPr>
@@ -8077,8 +8434,8 @@
         </p:blipFill>
         <p:spPr>
           <a:xfrm>
-            <a:off x="731520" y="1645920"/>
-            <a:ext cx="5029200" cy="3746968"/>
+            <a:off x="731520" y="1417320"/>
+            <a:ext cx="5120640" cy="3593328"/>
           </a:xfrm>
           <a:prstGeom prst="rect">
             <a:avLst/>
@@ -8093,8 +8450,8 @@
         </p:nvSpPr>
         <p:spPr>
           <a:xfrm>
-            <a:off x="6035040" y="1645920"/>
-            <a:ext cx="5394960" cy="4572000"/>
+            <a:off x="731520" y="4709160"/>
+            <a:ext cx="5120640" cy="1828800"/>
           </a:xfrm>
           <a:prstGeom prst="rect">
             <a:avLst/>
@@ -8138,8 +8495,8 @@
         </p:nvSpPr>
         <p:spPr>
           <a:xfrm>
-            <a:off x="6309360" y="1828800"/>
-            <a:ext cx="4846320" cy="4206240"/>
+            <a:off x="914400" y="4818888"/>
+            <a:ext cx="4754880" cy="1609344"/>
           </a:xfrm>
           <a:prstGeom prst="rect">
             <a:avLst/>
@@ -8154,91 +8511,213 @@
           <a:p>
             <a:pPr>
               <a:spcAft>
-                <a:spcPts val="1200"/>
-              </a:spcAft>
-              <a:defRPr sz="1600" b="1">
+                <a:spcPts val="400"/>
+              </a:spcAft>
+              <a:defRPr sz="1200" b="1">
                 <a:solidFill>
                   <a:srgbClr val="0F172A"/>
                 </a:solidFill>
               </a:defRPr>
             </a:pPr>
             <a:r>
-              <a:t>Correlation Diagnostics</a:t>
-            </a:r>
-          </a:p>
-          <a:p>
-            <a:pPr>
-              <a:spcAft>
-                <a:spcPts val="800"/>
-              </a:spcAft>
-              <a:defRPr sz="1100">
+              <a:t>Graph 7: Feature Correlation Matrix</a:t>
+            </a:r>
+          </a:p>
+          <a:p>
+            <a:pPr>
+              <a:spcAft>
+                <a:spcPts val="300"/>
+              </a:spcAft>
+              <a:defRPr sz="1000">
                 <a:solidFill>
                   <a:srgbClr val="1E293B"/>
                 </a:solidFill>
               </a:defRPr>
             </a:pPr>
             <a:r>
-              <a:t>- Feature Independence: Numerical predictors (distance, prep time, rating) exhibit virtually zero correlation with one another (|r| &lt; 0.05).</a:t>
-            </a:r>
-          </a:p>
-          <a:p>
-            <a:pPr>
-              <a:spcAft>
-                <a:spcPts val="800"/>
-              </a:spcAft>
-              <a:defRPr sz="1100">
+              <a:t>- Absence of Multicollinearity: Zero correlation between predictors (|r| &lt; 0.05 between distance &amp; prep time).</a:t>
+            </a:r>
+          </a:p>
+          <a:p>
+            <a:pPr>
+              <a:spcAft>
+                <a:spcPts val="300"/>
+              </a:spcAft>
+              <a:defRPr sz="1000">
                 <a:solidFill>
                   <a:srgbClr val="1E293B"/>
                 </a:solidFill>
               </a:defRPr>
             </a:pPr>
             <a:r>
-              <a:t>- Absence of Multicollinearity: The absence of inter-feature correlation ensures stable coefficient estimation in Linear and Polynomial regression without variance inflation.</a:t>
-            </a:r>
-          </a:p>
-          <a:p>
-            <a:pPr>
-              <a:spcAft>
-                <a:spcPts val="800"/>
-              </a:spcAft>
-              <a:defRPr sz="1100">
+              <a:t>- Target Correlation: Distance shows the highest quantitative linear correlation with delivery time (r = 0.65).</a:t>
+            </a:r>
+          </a:p>
+          <a:p>
+            <a:pPr>
+              <a:spcAft>
+                <a:spcPts val="300"/>
+              </a:spcAft>
+              <a:defRPr sz="1000">
                 <a:solidFill>
                   <a:srgbClr val="1E293B"/>
                 </a:solidFill>
               </a:defRPr>
             </a:pPr>
             <a:r>
-              <a:t>- Primary Predictor: Distance shows the highest quantitative linear correlation with delivery time (r = 0.65).</a:t>
-            </a:r>
-          </a:p>
-          <a:p>
-            <a:pPr>
-              <a:spcAft>
-                <a:spcPts val="800"/>
-              </a:spcAft>
-              <a:defRPr sz="1100">
+              <a:t>- Stability: Regression coefficients remain stable without variance inflation.</a:t>
+            </a:r>
+          </a:p>
+        </p:txBody>
+      </p:sp>
+      <p:pic>
+        <p:nvPicPr>
+          <p:cNvPr id="6" name="Picture 5" descr="8_partner_rating.png"/>
+          <p:cNvPicPr>
+            <a:picLocks noChangeAspect="1"/>
+          </p:cNvPicPr>
+          <p:nvPr/>
+        </p:nvPicPr>
+        <p:blipFill>
+          <a:blip r:embed="rId3"/>
+          <a:stretch>
+            <a:fillRect/>
+          </a:stretch>
+        </p:blipFill>
+        <p:spPr>
+          <a:xfrm>
+            <a:off x="6309360" y="1417320"/>
+            <a:ext cx="5120640" cy="3438144"/>
+          </a:xfrm>
+          <a:prstGeom prst="rect">
+            <a:avLst/>
+          </a:prstGeom>
+        </p:spPr>
+      </p:pic>
+      <p:sp>
+        <p:nvSpPr>
+          <p:cNvPr id="7" name="Rectangle 6"/>
+          <p:cNvSpPr/>
+          <p:nvPr/>
+        </p:nvSpPr>
+        <p:spPr>
+          <a:xfrm>
+            <a:off x="6309360" y="4709160"/>
+            <a:ext cx="5120640" cy="1828800"/>
+          </a:xfrm>
+          <a:prstGeom prst="rect">
+            <a:avLst/>
+          </a:prstGeom>
+          <a:solidFill>
+            <a:srgbClr val="F8FAFC"/>
+          </a:solidFill>
+          <a:ln w="12700">
+            <a:solidFill>
+              <a:srgbClr val="E2E8F0"/>
+            </a:solidFill>
+          </a:ln>
+        </p:spPr>
+        <p:style>
+          <a:lnRef idx="1">
+            <a:schemeClr val="accent1"/>
+          </a:lnRef>
+          <a:fillRef idx="3">
+            <a:schemeClr val="accent1"/>
+          </a:fillRef>
+          <a:effectRef idx="2">
+            <a:schemeClr val="accent1"/>
+          </a:effectRef>
+          <a:fontRef idx="minor">
+            <a:schemeClr val="lt1"/>
+          </a:fontRef>
+        </p:style>
+        <p:txBody>
+          <a:bodyPr rtlCol="0" anchor="ctr"/>
+          <a:lstStyle/>
+          <a:p>
+            <a:pPr algn="ctr"/>
+          </a:p>
+        </p:txBody>
+      </p:sp>
+      <p:sp>
+        <p:nvSpPr>
+          <p:cNvPr id="8" name="TextBox 7"/>
+          <p:cNvSpPr txBox="1"/>
+          <p:nvPr/>
+        </p:nvSpPr>
+        <p:spPr>
+          <a:xfrm>
+            <a:off x="6492240" y="4818888"/>
+            <a:ext cx="4754880" cy="1609344"/>
+          </a:xfrm>
+          <a:prstGeom prst="rect">
+            <a:avLst/>
+          </a:prstGeom>
+          <a:noFill/>
+        </p:spPr>
+        <p:txBody>
+          <a:bodyPr wrap="square">
+            <a:spAutoFit/>
+          </a:bodyPr>
+          <a:lstStyle/>
+          <a:p>
+            <a:pPr>
+              <a:spcAft>
+                <a:spcPts val="400"/>
+              </a:spcAft>
+              <a:defRPr sz="1200" b="1">
+                <a:solidFill>
+                  <a:srgbClr val="0F172A"/>
+                </a:solidFill>
+              </a:defRPr>
+            </a:pPr>
+            <a:r>
+              <a:t>Graph 8: Partner Rating vs Delivery Time</a:t>
+            </a:r>
+          </a:p>
+          <a:p>
+            <a:pPr>
+              <a:spcAft>
+                <a:spcPts val="300"/>
+              </a:spcAft>
+              <a:defRPr sz="1000">
                 <a:solidFill>
                   <a:srgbClr val="1E293B"/>
                 </a:solidFill>
               </a:defRPr>
             </a:pPr>
             <a:r>
-              <a:t>- Secondary Predictor: Kitchen preparation time exhibits solid linear correlation (r = 0.38).</a:t>
-            </a:r>
-          </a:p>
-          <a:p>
-            <a:pPr>
-              <a:spcAft>
-                <a:spcPts val="800"/>
-              </a:spcAft>
-              <a:defRPr sz="1100">
+              <a:t>- Partner Experience Effect: Higher-rated couriers (4.8 - 5.0 stars) show a slight negative slope with duration.</a:t>
+            </a:r>
+          </a:p>
+          <a:p>
+            <a:pPr>
+              <a:spcAft>
+                <a:spcPts val="300"/>
+              </a:spcAft>
+              <a:defRPr sz="1000">
                 <a:solidFill>
                   <a:srgbClr val="1E293B"/>
                 </a:solidFill>
               </a:defRPr>
             </a:pPr>
             <a:r>
-              <a:t>- Categorical Dominance: While categorical features (traffic, weather) are analyzed via ANOVA, one-hot encoding confirms their massive relative contribution to target variance.</a:t>
+              <a:t>- Pickup Efficiency: Experienced drivers save 2 to 3 minutes through faster restaurant pickup and parking.</a:t>
+            </a:r>
+          </a:p>
+          <a:p>
+            <a:pPr>
+              <a:spcAft>
+                <a:spcPts val="300"/>
+              </a:spcAft>
+              <a:defRPr sz="1000">
+                <a:solidFill>
+                  <a:srgbClr val="1E293B"/>
+                </a:solidFill>
+              </a:defRPr>
+            </a:pPr>
+            <a:r>
+              <a:t>- Secondary Influence: Partner rating is a refinement factor compared to the dominant impact of distance and traffic.</a:t>
             </a:r>
           </a:p>
         </p:txBody>
@@ -8269,7 +8748,7 @@
         </p:nvSpPr>
         <p:spPr>
           <a:xfrm>
-            <a:off x="731520" y="365760"/>
+            <a:off x="731520" y="320040"/>
             <a:ext cx="10698480" cy="1005840"/>
           </a:xfrm>
           <a:prstGeom prst="rect">
@@ -8285,7 +8764,7 @@
           <a:p>
             <a:pPr>
               <a:spcAft>
-                <a:spcPts val="400"/>
+                <a:spcPts val="200"/>
               </a:spcAft>
               <a:defRPr sz="1000" b="1">
                 <a:solidFill>
@@ -8300,7 +8779,7 @@
           </a:p>
           <a:p>
             <a:pPr>
-              <a:defRPr sz="2200" b="1">
+              <a:defRPr sz="2100" b="1">
                 <a:solidFill>
                   <a:srgbClr val="0F172A"/>
                 </a:solidFill>
@@ -8308,7 +8787,7 @@
               </a:defRPr>
             </a:pPr>
             <a:r>
-              <a:t>Architectural Overview of the 5 Regression Algorithms</a:t>
+              <a:t>Architectural Breakdown of the 5 Regression Algorithms</a:t>
             </a:r>
           </a:p>
         </p:txBody>
@@ -8321,8 +8800,8 @@
         </p:nvSpPr>
         <p:spPr>
           <a:xfrm>
-            <a:off x="731520" y="1645920"/>
-            <a:ext cx="10698480" cy="804672"/>
+            <a:off x="731520" y="1463040"/>
+            <a:ext cx="10698480" cy="841248"/>
           </a:xfrm>
           <a:prstGeom prst="rect">
             <a:avLst/>
@@ -8366,8 +8845,8 @@
         </p:nvSpPr>
         <p:spPr>
           <a:xfrm>
-            <a:off x="914400" y="1719072"/>
-            <a:ext cx="10332720" cy="658368"/>
+            <a:off x="914400" y="1536192"/>
+            <a:ext cx="10332720" cy="694944"/>
           </a:xfrm>
           <a:prstGeom prst="rect">
             <a:avLst/>
@@ -8388,7 +8867,7 @@
               </a:defRPr>
             </a:pPr>
             <a:r>
-              <a:t>1. Linear Regression</a:t>
+              <a:t>1. Linear Regression (Parametric Baseline)</a:t>
             </a:r>
           </a:p>
           <a:p>
@@ -8400,7 +8879,7 @@
               </a:defRPr>
             </a:pPr>
             <a:r>
-              <a:t>Architecture: Parametric Baseline | Description: Models linear relationship: y = w0 + sum(wi * xi). Fast and interpretable, but fails to capture non-linear traffic and weather interaction effects.</a:t>
+              <a:t>Models linear relationship: y = w0 + sum(wi * xi). Fast and interpretable, but unable to model non-linear traffic velocity compounding.</a:t>
             </a:r>
           </a:p>
         </p:txBody>
@@ -8413,8 +8892,8 @@
         </p:nvSpPr>
         <p:spPr>
           <a:xfrm>
-            <a:off x="731520" y="2560320"/>
-            <a:ext cx="10698480" cy="804672"/>
+            <a:off x="731520" y="2423160"/>
+            <a:ext cx="10698480" cy="841248"/>
           </a:xfrm>
           <a:prstGeom prst="rect">
             <a:avLst/>
@@ -8458,8 +8937,8 @@
         </p:nvSpPr>
         <p:spPr>
           <a:xfrm>
-            <a:off x="914400" y="2633472"/>
-            <a:ext cx="10332720" cy="658368"/>
+            <a:off x="914400" y="2496312"/>
+            <a:ext cx="10332720" cy="694944"/>
           </a:xfrm>
           <a:prstGeom prst="rect">
             <a:avLst/>
@@ -8480,7 +8959,7 @@
               </a:defRPr>
             </a:pPr>
             <a:r>
-              <a:t>2. Polynomial Regression</a:t>
+              <a:t>2. Polynomial Regression (Degree 2 Non-Linear)</a:t>
             </a:r>
           </a:p>
           <a:p>
@@ -8492,7 +8971,7 @@
               </a:defRPr>
             </a:pPr>
             <a:r>
-              <a:t>Architecture: Non-Linear Feature Expander | Description: Generates degree-2 polynomial and cross-product interaction terms (e.g. distance * traffic). Captures non-linear compounding delays with moderate parameter growth.</a:t>
+              <a:t>Expands feature space with quadratic and interaction terms (e.g., distance * traffic). Captures non-linear compounding delays.</a:t>
             </a:r>
           </a:p>
         </p:txBody>
@@ -8505,8 +8984,8 @@
         </p:nvSpPr>
         <p:spPr>
           <a:xfrm>
-            <a:off x="731520" y="3474720"/>
-            <a:ext cx="10698480" cy="804672"/>
+            <a:off x="731520" y="3383280"/>
+            <a:ext cx="10698480" cy="841248"/>
           </a:xfrm>
           <a:prstGeom prst="rect">
             <a:avLst/>
@@ -8550,8 +9029,8 @@
         </p:nvSpPr>
         <p:spPr>
           <a:xfrm>
-            <a:off x="914400" y="3547872"/>
-            <a:ext cx="10332720" cy="658368"/>
+            <a:off x="914400" y="3456432"/>
+            <a:ext cx="10332720" cy="694944"/>
           </a:xfrm>
           <a:prstGeom prst="rect">
             <a:avLst/>
@@ -8572,7 +9051,7 @@
               </a:defRPr>
             </a:pPr>
             <a:r>
-              <a:t>3. Decision Tree</a:t>
+              <a:t>3. Decision Tree (Orthogonal Partitioner)</a:t>
             </a:r>
           </a:p>
           <a:p>
@@ -8584,7 +9063,7 @@
               </a:defRPr>
             </a:pPr>
             <a:r>
-              <a:t>Architecture: Rule-Based Partitioner | Description: Recursively splits feature space into orthogonal rectangular regions based on MSE reduction. Captures step thresholds but prone to high variance.</a:t>
+              <a:t>Recursively splits feature space based on MSE reduction. Captures step-thresholds but exhibits high variance on continuous targets.</a:t>
             </a:r>
           </a:p>
         </p:txBody>
@@ -8597,8 +9076,8 @@
         </p:nvSpPr>
         <p:spPr>
           <a:xfrm>
-            <a:off x="731520" y="4389120"/>
-            <a:ext cx="10698480" cy="804672"/>
+            <a:off x="731520" y="4343400"/>
+            <a:ext cx="10698480" cy="841248"/>
           </a:xfrm>
           <a:prstGeom prst="rect">
             <a:avLst/>
@@ -8642,8 +9121,8 @@
         </p:nvSpPr>
         <p:spPr>
           <a:xfrm>
-            <a:off x="914400" y="4462272"/>
-            <a:ext cx="10332720" cy="658368"/>
+            <a:off x="914400" y="4416552"/>
+            <a:ext cx="10332720" cy="694944"/>
           </a:xfrm>
           <a:prstGeom prst="rect">
             <a:avLst/>
@@ -8664,7 +9143,7 @@
               </a:defRPr>
             </a:pPr>
             <a:r>
-              <a:t>4. Random Forest</a:t>
+              <a:t>4. Random Forest (Bagging Ensemble (100 Trees))</a:t>
             </a:r>
           </a:p>
           <a:p>
@@ -8676,7 +9155,7 @@
               </a:defRPr>
             </a:pPr>
             <a:r>
-              <a:t>Architecture: Bagging Ensemble | Description: Trains 100 decorrelated decision trees using bootstrap aggregating and random feature subsets. Drastically reduces variance and resists overfitting.</a:t>
+              <a:t>Averages 100 decorrelated decision trees built on bootstrap samples. Substantially reduces variance and resists overfitting.</a:t>
             </a:r>
           </a:p>
         </p:txBody>
@@ -8690,7 +9169,7 @@
         <p:spPr>
           <a:xfrm>
             <a:off x="731520" y="5303520"/>
-            <a:ext cx="10698480" cy="804672"/>
+            <a:ext cx="10698480" cy="841248"/>
           </a:xfrm>
           <a:prstGeom prst="rect">
             <a:avLst/>
@@ -8735,7 +9214,7 @@
         <p:spPr>
           <a:xfrm>
             <a:off x="914400" y="5376672"/>
-            <a:ext cx="10332720" cy="658368"/>
+            <a:ext cx="10332720" cy="694944"/>
           </a:xfrm>
           <a:prstGeom prst="rect">
             <a:avLst/>
@@ -8756,7 +9235,7 @@
               </a:defRPr>
             </a:pPr>
             <a:r>
-              <a:t>5. Gradient Boosting</a:t>
+              <a:t>5. Gradient Boosting (Sequential Boosting Ensemble)</a:t>
             </a:r>
           </a:p>
           <a:p>
@@ -8768,7 +9247,7 @@
               </a:defRPr>
             </a:pPr>
             <a:r>
-              <a:t>Architecture: Sequential Boosting Ensemble | Description: Sequentially fits trees to the pseudo-residuals of previous iterations using gradient descent. Achieves the highest predictive accuracy and minimal error.</a:t>
+              <a:t>Sequentially trains shallow trees on pseudo-residuals using gradient descent. Achieves the highest predictive accuracy and lowest errors.</a:t>
             </a:r>
           </a:p>
         </p:txBody>
@@ -8799,7 +9278,7 @@
         </p:nvSpPr>
         <p:spPr>
           <a:xfrm>
-            <a:off x="731520" y="365760"/>
+            <a:off x="731520" y="320040"/>
             <a:ext cx="10698480" cy="1005840"/>
           </a:xfrm>
           <a:prstGeom prst="rect">
@@ -8815,7 +9294,7 @@
           <a:p>
             <a:pPr>
               <a:spcAft>
-                <a:spcPts val="400"/>
+                <a:spcPts val="200"/>
               </a:spcAft>
               <a:defRPr sz="1000" b="1">
                 <a:solidFill>
@@ -8830,7 +9309,7 @@
           </a:p>
           <a:p>
             <a:pPr>
-              <a:defRPr sz="2200" b="1">
+              <a:defRPr sz="2100" b="1">
                 <a:solidFill>
                   <a:srgbClr val="0F172A"/>
                 </a:solidFill>
@@ -8838,14 +9317,14 @@
               </a:defRPr>
             </a:pPr>
             <a:r>
-              <a:t>Empirical Benchmark: Comparative Performance Across All Models</a:t>
+              <a:t>Empirical Benchmark: Accuracy (R2) &amp; Error Comparison Across Models</a:t>
             </a:r>
           </a:p>
         </p:txBody>
       </p:sp>
       <p:pic>
         <p:nvPicPr>
-          <p:cNvPr id="3" name="Picture 2" descr="5_model_comparison.png"/>
+          <p:cNvPr id="3" name="Picture 2" descr="9_r2_comparison.png"/>
           <p:cNvPicPr>
             <a:picLocks noChangeAspect="1"/>
           </p:cNvPicPr>
@@ -8859,884 +9338,294 @@
         </p:blipFill>
         <p:spPr>
           <a:xfrm>
-            <a:off x="731520" y="1463040"/>
-            <a:ext cx="10698480" cy="3395280"/>
+            <a:off x="731520" y="1417320"/>
+            <a:ext cx="5120640" cy="3433444"/>
           </a:xfrm>
           <a:prstGeom prst="rect">
             <a:avLst/>
           </a:prstGeom>
         </p:spPr>
       </p:pic>
-      <p:graphicFrame>
-        <p:nvGraphicFramePr>
-          <p:cNvPr id="4" name="Table 3"/>
-          <p:cNvGraphicFramePr>
-            <a:graphicFrameLocks noGrp="1"/>
-          </p:cNvGraphicFramePr>
-          <p:nvPr/>
-        </p:nvGraphicFramePr>
-        <p:xfrm>
-          <a:off x="731520" y="4389120"/>
-          <a:ext cx="10698480" cy="2011680"/>
-        </p:xfrm>
-        <a:graphic>
-          <a:graphicData uri="http://schemas.openxmlformats.org/drawingml/2006/table">
-            <a:tbl>
-              <a:tblPr firstRow="1" bandRow="1">
-                <a:tableStyleId>{5C22544A-7EE6-4342-B048-85BDC9FD1C3A}</a:tableStyleId>
-              </a:tblPr>
-              <a:tblGrid>
-                <a:gridCol w="1783080"/>
-                <a:gridCol w="1783080"/>
-                <a:gridCol w="1783080"/>
-                <a:gridCol w="1783080"/>
-                <a:gridCol w="1783080"/>
-                <a:gridCol w="1783080"/>
-              </a:tblGrid>
-              <a:tr h="335280">
-                <a:tc>
-                  <a:txBody>
-                    <a:bodyPr/>
-                    <a:lstStyle/>
-                    <a:p>
-                      <a:pPr>
-                        <a:defRPr b="1" sz="1000">
-                          <a:solidFill>
-                            <a:srgbClr val="FFFFFF"/>
-                          </a:solidFill>
-                        </a:defRPr>
-                      </a:pPr>
-                      <a:r>
-                        <a:t>Algorithm</a:t>
-                      </a:r>
-                    </a:p>
-                  </a:txBody>
-                  <a:tcPr>
-                    <a:solidFill>
-                      <a:srgbClr val="0F172A"/>
-                    </a:solidFill>
-                  </a:tcPr>
-                </a:tc>
-                <a:tc>
-                  <a:txBody>
-                    <a:bodyPr/>
-                    <a:lstStyle/>
-                    <a:p>
-                      <a:pPr>
-                        <a:defRPr b="1" sz="1000">
-                          <a:solidFill>
-                            <a:srgbClr val="FFFFFF"/>
-                          </a:solidFill>
-                        </a:defRPr>
-                      </a:pPr>
-                      <a:r>
-                        <a:t>Test R2 Score</a:t>
-                      </a:r>
-                    </a:p>
-                  </a:txBody>
-                  <a:tcPr>
-                    <a:solidFill>
-                      <a:srgbClr val="0F172A"/>
-                    </a:solidFill>
-                  </a:tcPr>
-                </a:tc>
-                <a:tc>
-                  <a:txBody>
-                    <a:bodyPr/>
-                    <a:lstStyle/>
-                    <a:p>
-                      <a:pPr>
-                        <a:defRPr b="1" sz="1000">
-                          <a:solidFill>
-                            <a:srgbClr val="FFFFFF"/>
-                          </a:solidFill>
-                        </a:defRPr>
-                      </a:pPr>
-                      <a:r>
-                        <a:t>5-Fold CV R2</a:t>
-                      </a:r>
-                    </a:p>
-                  </a:txBody>
-                  <a:tcPr>
-                    <a:solidFill>
-                      <a:srgbClr val="0F172A"/>
-                    </a:solidFill>
-                  </a:tcPr>
-                </a:tc>
-                <a:tc>
-                  <a:txBody>
-                    <a:bodyPr/>
-                    <a:lstStyle/>
-                    <a:p>
-                      <a:pPr>
-                        <a:defRPr b="1" sz="1000">
-                          <a:solidFill>
-                            <a:srgbClr val="FFFFFF"/>
-                          </a:solidFill>
-                        </a:defRPr>
-                      </a:pPr>
-                      <a:r>
-                        <a:t>MSE</a:t>
-                      </a:r>
-                    </a:p>
-                  </a:txBody>
-                  <a:tcPr>
-                    <a:solidFill>
-                      <a:srgbClr val="0F172A"/>
-                    </a:solidFill>
-                  </a:tcPr>
-                </a:tc>
-                <a:tc>
-                  <a:txBody>
-                    <a:bodyPr/>
-                    <a:lstStyle/>
-                    <a:p>
-                      <a:pPr>
-                        <a:defRPr b="1" sz="1000">
-                          <a:solidFill>
-                            <a:srgbClr val="FFFFFF"/>
-                          </a:solidFill>
-                        </a:defRPr>
-                      </a:pPr>
-                      <a:r>
-                        <a:t>RMSE (min)</a:t>
-                      </a:r>
-                    </a:p>
-                  </a:txBody>
-                  <a:tcPr>
-                    <a:solidFill>
-                      <a:srgbClr val="0F172A"/>
-                    </a:solidFill>
-                  </a:tcPr>
-                </a:tc>
-                <a:tc>
-                  <a:txBody>
-                    <a:bodyPr/>
-                    <a:lstStyle/>
-                    <a:p>
-                      <a:pPr>
-                        <a:defRPr b="1" sz="1000">
-                          <a:solidFill>
-                            <a:srgbClr val="FFFFFF"/>
-                          </a:solidFill>
-                        </a:defRPr>
-                      </a:pPr>
-                      <a:r>
-                        <a:t>MAE (min)</a:t>
-                      </a:r>
-                    </a:p>
-                  </a:txBody>
-                  <a:tcPr>
-                    <a:solidFill>
-                      <a:srgbClr val="0F172A"/>
-                    </a:solidFill>
-                  </a:tcPr>
-                </a:tc>
-              </a:tr>
-              <a:tr h="335280">
-                <a:tc>
-                  <a:txBody>
-                    <a:bodyPr/>
-                    <a:lstStyle/>
-                    <a:p>
-                      <a:pPr>
-                        <a:defRPr b="1" sz="950">
-                          <a:solidFill>
-                            <a:srgbClr val="166534"/>
-                          </a:solidFill>
-                        </a:defRPr>
-                      </a:pPr>
-                      <a:r>
-                        <a:t>Gradient Boosting Regressor</a:t>
-                      </a:r>
-                    </a:p>
-                  </a:txBody>
-                  <a:tcPr>
-                    <a:solidFill>
-                      <a:srgbClr val="F0FDF4"/>
-                    </a:solidFill>
-                  </a:tcPr>
-                </a:tc>
-                <a:tc>
-                  <a:txBody>
-                    <a:bodyPr/>
-                    <a:lstStyle/>
-                    <a:p>
-                      <a:pPr>
-                        <a:defRPr b="1" sz="950">
-                          <a:solidFill>
-                            <a:srgbClr val="166534"/>
-                          </a:solidFill>
-                        </a:defRPr>
-                      </a:pPr>
-                      <a:r>
-                        <a:t>0.7545</a:t>
-                      </a:r>
-                    </a:p>
-                  </a:txBody>
-                  <a:tcPr>
-                    <a:solidFill>
-                      <a:srgbClr val="F0FDF4"/>
-                    </a:solidFill>
-                  </a:tcPr>
-                </a:tc>
-                <a:tc>
-                  <a:txBody>
-                    <a:bodyPr/>
-                    <a:lstStyle/>
-                    <a:p>
-                      <a:pPr>
-                        <a:defRPr b="1" sz="950">
-                          <a:solidFill>
-                            <a:srgbClr val="166534"/>
-                          </a:solidFill>
-                        </a:defRPr>
-                      </a:pPr>
-                      <a:r>
-                        <a:t>0.7783</a:t>
-                      </a:r>
-                    </a:p>
-                  </a:txBody>
-                  <a:tcPr>
-                    <a:solidFill>
-                      <a:srgbClr val="F0FDF4"/>
-                    </a:solidFill>
-                  </a:tcPr>
-                </a:tc>
-                <a:tc>
-                  <a:txBody>
-                    <a:bodyPr/>
-                    <a:lstStyle/>
-                    <a:p>
-                      <a:pPr>
-                        <a:defRPr b="1" sz="950">
-                          <a:solidFill>
-                            <a:srgbClr val="166534"/>
-                          </a:solidFill>
-                        </a:defRPr>
-                      </a:pPr>
-                      <a:r>
-                        <a:t>87.65</a:t>
-                      </a:r>
-                    </a:p>
-                  </a:txBody>
-                  <a:tcPr>
-                    <a:solidFill>
-                      <a:srgbClr val="F0FDF4"/>
-                    </a:solidFill>
-                  </a:tcPr>
-                </a:tc>
-                <a:tc>
-                  <a:txBody>
-                    <a:bodyPr/>
-                    <a:lstStyle/>
-                    <a:p>
-                      <a:pPr>
-                        <a:defRPr b="1" sz="950">
-                          <a:solidFill>
-                            <a:srgbClr val="166534"/>
-                          </a:solidFill>
-                        </a:defRPr>
-                      </a:pPr>
-                      <a:r>
-                        <a:t>9.36 min</a:t>
-                      </a:r>
-                    </a:p>
-                  </a:txBody>
-                  <a:tcPr>
-                    <a:solidFill>
-                      <a:srgbClr val="F0FDF4"/>
-                    </a:solidFill>
-                  </a:tcPr>
-                </a:tc>
-                <a:tc>
-                  <a:txBody>
-                    <a:bodyPr/>
-                    <a:lstStyle/>
-                    <a:p>
-                      <a:pPr>
-                        <a:defRPr b="1" sz="950">
-                          <a:solidFill>
-                            <a:srgbClr val="166534"/>
-                          </a:solidFill>
-                        </a:defRPr>
-                      </a:pPr>
-                      <a:r>
-                        <a:t>5.02 min</a:t>
-                      </a:r>
-                    </a:p>
-                  </a:txBody>
-                  <a:tcPr>
-                    <a:solidFill>
-                      <a:srgbClr val="F0FDF4"/>
-                    </a:solidFill>
-                  </a:tcPr>
-                </a:tc>
-              </a:tr>
-              <a:tr h="335280">
-                <a:tc>
-                  <a:txBody>
-                    <a:bodyPr/>
-                    <a:lstStyle/>
-                    <a:p>
-                      <a:pPr>
-                        <a:defRPr b="0" sz="950">
-                          <a:solidFill>
-                            <a:srgbClr val="1E293B"/>
-                          </a:solidFill>
-                        </a:defRPr>
-                      </a:pPr>
-                      <a:r>
-                        <a:t>Polynomial Regression (Deg 2)</a:t>
-                      </a:r>
-                    </a:p>
-                  </a:txBody>
-                  <a:tcPr>
-                    <a:solidFill>
-                      <a:srgbClr val="F8FAFC"/>
-                    </a:solidFill>
-                  </a:tcPr>
-                </a:tc>
-                <a:tc>
-                  <a:txBody>
-                    <a:bodyPr/>
-                    <a:lstStyle/>
-                    <a:p>
-                      <a:pPr>
-                        <a:defRPr b="0" sz="950">
-                          <a:solidFill>
-                            <a:srgbClr val="1E293B"/>
-                          </a:solidFill>
-                        </a:defRPr>
-                      </a:pPr>
-                      <a:r>
-                        <a:t>0.7538</a:t>
-                      </a:r>
-                    </a:p>
-                  </a:txBody>
-                  <a:tcPr>
-                    <a:solidFill>
-                      <a:srgbClr val="F8FAFC"/>
-                    </a:solidFill>
-                  </a:tcPr>
-                </a:tc>
-                <a:tc>
-                  <a:txBody>
-                    <a:bodyPr/>
-                    <a:lstStyle/>
-                    <a:p>
-                      <a:pPr>
-                        <a:defRPr b="0" sz="950">
-                          <a:solidFill>
-                            <a:srgbClr val="1E293B"/>
-                          </a:solidFill>
-                        </a:defRPr>
-                      </a:pPr>
-                      <a:r>
-                        <a:t>0.7753</a:t>
-                      </a:r>
-                    </a:p>
-                  </a:txBody>
-                  <a:tcPr>
-                    <a:solidFill>
-                      <a:srgbClr val="F8FAFC"/>
-                    </a:solidFill>
-                  </a:tcPr>
-                </a:tc>
-                <a:tc>
-                  <a:txBody>
-                    <a:bodyPr/>
-                    <a:lstStyle/>
-                    <a:p>
-                      <a:pPr>
-                        <a:defRPr b="0" sz="950">
-                          <a:solidFill>
-                            <a:srgbClr val="1E293B"/>
-                          </a:solidFill>
-                        </a:defRPr>
-                      </a:pPr>
-                      <a:r>
-                        <a:t>87.88</a:t>
-                      </a:r>
-                    </a:p>
-                  </a:txBody>
-                  <a:tcPr>
-                    <a:solidFill>
-                      <a:srgbClr val="F8FAFC"/>
-                    </a:solidFill>
-                  </a:tcPr>
-                </a:tc>
-                <a:tc>
-                  <a:txBody>
-                    <a:bodyPr/>
-                    <a:lstStyle/>
-                    <a:p>
-                      <a:pPr>
-                        <a:defRPr b="0" sz="950">
-                          <a:solidFill>
-                            <a:srgbClr val="1E293B"/>
-                          </a:solidFill>
-                        </a:defRPr>
-                      </a:pPr>
-                      <a:r>
-                        <a:t>9.37 min</a:t>
-                      </a:r>
-                    </a:p>
-                  </a:txBody>
-                  <a:tcPr>
-                    <a:solidFill>
-                      <a:srgbClr val="F8FAFC"/>
-                    </a:solidFill>
-                  </a:tcPr>
-                </a:tc>
-                <a:tc>
-                  <a:txBody>
-                    <a:bodyPr/>
-                    <a:lstStyle/>
-                    <a:p>
-                      <a:pPr>
-                        <a:defRPr b="0" sz="950">
-                          <a:solidFill>
-                            <a:srgbClr val="1E293B"/>
-                          </a:solidFill>
-                        </a:defRPr>
-                      </a:pPr>
-                      <a:r>
-                        <a:t>5.16 min</a:t>
-                      </a:r>
-                    </a:p>
-                  </a:txBody>
-                  <a:tcPr>
-                    <a:solidFill>
-                      <a:srgbClr val="F8FAFC"/>
-                    </a:solidFill>
-                  </a:tcPr>
-                </a:tc>
-              </a:tr>
-              <a:tr h="335280">
-                <a:tc>
-                  <a:txBody>
-                    <a:bodyPr/>
-                    <a:lstStyle/>
-                    <a:p>
-                      <a:pPr>
-                        <a:defRPr b="0" sz="950">
-                          <a:solidFill>
-                            <a:srgbClr val="1E293B"/>
-                          </a:solidFill>
-                        </a:defRPr>
-                      </a:pPr>
-                      <a:r>
-                        <a:t>Random Forest Regressor</a:t>
-                      </a:r>
-                    </a:p>
-                  </a:txBody>
-                  <a:tcPr>
-                    <a:solidFill>
-                      <a:srgbClr val="FFFFFF"/>
-                    </a:solidFill>
-                  </a:tcPr>
-                </a:tc>
-                <a:tc>
-                  <a:txBody>
-                    <a:bodyPr/>
-                    <a:lstStyle/>
-                    <a:p>
-                      <a:pPr>
-                        <a:defRPr b="0" sz="950">
-                          <a:solidFill>
-                            <a:srgbClr val="1E293B"/>
-                          </a:solidFill>
-                        </a:defRPr>
-                      </a:pPr>
-                      <a:r>
-                        <a:t>0.7401</a:t>
-                      </a:r>
-                    </a:p>
-                  </a:txBody>
-                  <a:tcPr>
-                    <a:solidFill>
-                      <a:srgbClr val="FFFFFF"/>
-                    </a:solidFill>
-                  </a:tcPr>
-                </a:tc>
-                <a:tc>
-                  <a:txBody>
-                    <a:bodyPr/>
-                    <a:lstStyle/>
-                    <a:p>
-                      <a:pPr>
-                        <a:defRPr b="0" sz="950">
-                          <a:solidFill>
-                            <a:srgbClr val="1E293B"/>
-                          </a:solidFill>
-                        </a:defRPr>
-                      </a:pPr>
-                      <a:r>
-                        <a:t>0.7541</a:t>
-                      </a:r>
-                    </a:p>
-                  </a:txBody>
-                  <a:tcPr>
-                    <a:solidFill>
-                      <a:srgbClr val="FFFFFF"/>
-                    </a:solidFill>
-                  </a:tcPr>
-                </a:tc>
-                <a:tc>
-                  <a:txBody>
-                    <a:bodyPr/>
-                    <a:lstStyle/>
-                    <a:p>
-                      <a:pPr>
-                        <a:defRPr b="0" sz="950">
-                          <a:solidFill>
-                            <a:srgbClr val="1E293B"/>
-                          </a:solidFill>
-                        </a:defRPr>
-                      </a:pPr>
-                      <a:r>
-                        <a:t>92.78</a:t>
-                      </a:r>
-                    </a:p>
-                  </a:txBody>
-                  <a:tcPr>
-                    <a:solidFill>
-                      <a:srgbClr val="FFFFFF"/>
-                    </a:solidFill>
-                  </a:tcPr>
-                </a:tc>
-                <a:tc>
-                  <a:txBody>
-                    <a:bodyPr/>
-                    <a:lstStyle/>
-                    <a:p>
-                      <a:pPr>
-                        <a:defRPr b="0" sz="950">
-                          <a:solidFill>
-                            <a:srgbClr val="1E293B"/>
-                          </a:solidFill>
-                        </a:defRPr>
-                      </a:pPr>
-                      <a:r>
-                        <a:t>9.63 min</a:t>
-                      </a:r>
-                    </a:p>
-                  </a:txBody>
-                  <a:tcPr>
-                    <a:solidFill>
-                      <a:srgbClr val="FFFFFF"/>
-                    </a:solidFill>
-                  </a:tcPr>
-                </a:tc>
-                <a:tc>
-                  <a:txBody>
-                    <a:bodyPr/>
-                    <a:lstStyle/>
-                    <a:p>
-                      <a:pPr>
-                        <a:defRPr b="0" sz="950">
-                          <a:solidFill>
-                            <a:srgbClr val="1E293B"/>
-                          </a:solidFill>
-                        </a:defRPr>
-                      </a:pPr>
-                      <a:r>
-                        <a:t>5.40 min</a:t>
-                      </a:r>
-                    </a:p>
-                  </a:txBody>
-                  <a:tcPr>
-                    <a:solidFill>
-                      <a:srgbClr val="FFFFFF"/>
-                    </a:solidFill>
-                  </a:tcPr>
-                </a:tc>
-              </a:tr>
-              <a:tr h="335280">
-                <a:tc>
-                  <a:txBody>
-                    <a:bodyPr/>
-                    <a:lstStyle/>
-                    <a:p>
-                      <a:pPr>
-                        <a:defRPr b="0" sz="950">
-                          <a:solidFill>
-                            <a:srgbClr val="1E293B"/>
-                          </a:solidFill>
-                        </a:defRPr>
-                      </a:pPr>
-                      <a:r>
-                        <a:t>Linear Regression</a:t>
-                      </a:r>
-                    </a:p>
-                  </a:txBody>
-                  <a:tcPr>
-                    <a:solidFill>
-                      <a:srgbClr val="F8FAFC"/>
-                    </a:solidFill>
-                  </a:tcPr>
-                </a:tc>
-                <a:tc>
-                  <a:txBody>
-                    <a:bodyPr/>
-                    <a:lstStyle/>
-                    <a:p>
-                      <a:pPr>
-                        <a:defRPr b="0" sz="950">
-                          <a:solidFill>
-                            <a:srgbClr val="1E293B"/>
-                          </a:solidFill>
-                        </a:defRPr>
-                      </a:pPr>
-                      <a:r>
-                        <a:t>0.7273</a:t>
-                      </a:r>
-                    </a:p>
-                  </a:txBody>
-                  <a:tcPr>
-                    <a:solidFill>
-                      <a:srgbClr val="F8FAFC"/>
-                    </a:solidFill>
-                  </a:tcPr>
-                </a:tc>
-                <a:tc>
-                  <a:txBody>
-                    <a:bodyPr/>
-                    <a:lstStyle/>
-                    <a:p>
-                      <a:pPr>
-                        <a:defRPr b="0" sz="950">
-                          <a:solidFill>
-                            <a:srgbClr val="1E293B"/>
-                          </a:solidFill>
-                        </a:defRPr>
-                      </a:pPr>
-                      <a:r>
-                        <a:t>0.7483</a:t>
-                      </a:r>
-                    </a:p>
-                  </a:txBody>
-                  <a:tcPr>
-                    <a:solidFill>
-                      <a:srgbClr val="F8FAFC"/>
-                    </a:solidFill>
-                  </a:tcPr>
-                </a:tc>
-                <a:tc>
-                  <a:txBody>
-                    <a:bodyPr/>
-                    <a:lstStyle/>
-                    <a:p>
-                      <a:pPr>
-                        <a:defRPr b="0" sz="950">
-                          <a:solidFill>
-                            <a:srgbClr val="1E293B"/>
-                          </a:solidFill>
-                        </a:defRPr>
-                      </a:pPr>
-                      <a:r>
-                        <a:t>97.36</a:t>
-                      </a:r>
-                    </a:p>
-                  </a:txBody>
-                  <a:tcPr>
-                    <a:solidFill>
-                      <a:srgbClr val="F8FAFC"/>
-                    </a:solidFill>
-                  </a:tcPr>
-                </a:tc>
-                <a:tc>
-                  <a:txBody>
-                    <a:bodyPr/>
-                    <a:lstStyle/>
-                    <a:p>
-                      <a:pPr>
-                        <a:defRPr b="0" sz="950">
-                          <a:solidFill>
-                            <a:srgbClr val="1E293B"/>
-                          </a:solidFill>
-                        </a:defRPr>
-                      </a:pPr>
-                      <a:r>
-                        <a:t>9.87 min</a:t>
-                      </a:r>
-                    </a:p>
-                  </a:txBody>
-                  <a:tcPr>
-                    <a:solidFill>
-                      <a:srgbClr val="F8FAFC"/>
-                    </a:solidFill>
-                  </a:tcPr>
-                </a:tc>
-                <a:tc>
-                  <a:txBody>
-                    <a:bodyPr/>
-                    <a:lstStyle/>
-                    <a:p>
-                      <a:pPr>
-                        <a:defRPr b="0" sz="950">
-                          <a:solidFill>
-                            <a:srgbClr val="1E293B"/>
-                          </a:solidFill>
-                        </a:defRPr>
-                      </a:pPr>
-                      <a:r>
-                        <a:t>5.68 min</a:t>
-                      </a:r>
-                    </a:p>
-                  </a:txBody>
-                  <a:tcPr>
-                    <a:solidFill>
-                      <a:srgbClr val="F8FAFC"/>
-                    </a:solidFill>
-                  </a:tcPr>
-                </a:tc>
-              </a:tr>
-              <a:tr h="335280">
-                <a:tc>
-                  <a:txBody>
-                    <a:bodyPr/>
-                    <a:lstStyle/>
-                    <a:p>
-                      <a:pPr>
-                        <a:defRPr b="0" sz="950">
-                          <a:solidFill>
-                            <a:srgbClr val="1E293B"/>
-                          </a:solidFill>
-                        </a:defRPr>
-                      </a:pPr>
-                      <a:r>
-                        <a:t>Decision Tree Regressor</a:t>
-                      </a:r>
-                    </a:p>
-                  </a:txBody>
-                  <a:tcPr>
-                    <a:solidFill>
-                      <a:srgbClr val="FFFFFF"/>
-                    </a:solidFill>
-                  </a:tcPr>
-                </a:tc>
-                <a:tc>
-                  <a:txBody>
-                    <a:bodyPr/>
-                    <a:lstStyle/>
-                    <a:p>
-                      <a:pPr>
-                        <a:defRPr b="0" sz="950">
-                          <a:solidFill>
-                            <a:srgbClr val="1E293B"/>
-                          </a:solidFill>
-                        </a:defRPr>
-                      </a:pPr>
-                      <a:r>
-                        <a:t>0.6592</a:t>
-                      </a:r>
-                    </a:p>
-                  </a:txBody>
-                  <a:tcPr>
-                    <a:solidFill>
-                      <a:srgbClr val="FFFFFF"/>
-                    </a:solidFill>
-                  </a:tcPr>
-                </a:tc>
-                <a:tc>
-                  <a:txBody>
-                    <a:bodyPr/>
-                    <a:lstStyle/>
-                    <a:p>
-                      <a:pPr>
-                        <a:defRPr b="0" sz="950">
-                          <a:solidFill>
-                            <a:srgbClr val="1E293B"/>
-                          </a:solidFill>
-                        </a:defRPr>
-                      </a:pPr>
-                      <a:r>
-                        <a:t>0.6868</a:t>
-                      </a:r>
-                    </a:p>
-                  </a:txBody>
-                  <a:tcPr>
-                    <a:solidFill>
-                      <a:srgbClr val="FFFFFF"/>
-                    </a:solidFill>
-                  </a:tcPr>
-                </a:tc>
-                <a:tc>
-                  <a:txBody>
-                    <a:bodyPr/>
-                    <a:lstStyle/>
-                    <a:p>
-                      <a:pPr>
-                        <a:defRPr b="0" sz="950">
-                          <a:solidFill>
-                            <a:srgbClr val="1E293B"/>
-                          </a:solidFill>
-                        </a:defRPr>
-                      </a:pPr>
-                      <a:r>
-                        <a:t>121.65</a:t>
-                      </a:r>
-                    </a:p>
-                  </a:txBody>
-                  <a:tcPr>
-                    <a:solidFill>
-                      <a:srgbClr val="FFFFFF"/>
-                    </a:solidFill>
-                  </a:tcPr>
-                </a:tc>
-                <a:tc>
-                  <a:txBody>
-                    <a:bodyPr/>
-                    <a:lstStyle/>
-                    <a:p>
-                      <a:pPr>
-                        <a:defRPr b="0" sz="950">
-                          <a:solidFill>
-                            <a:srgbClr val="1E293B"/>
-                          </a:solidFill>
-                        </a:defRPr>
-                      </a:pPr>
-                      <a:r>
-                        <a:t>11.03 min</a:t>
-                      </a:r>
-                    </a:p>
-                  </a:txBody>
-                  <a:tcPr>
-                    <a:solidFill>
-                      <a:srgbClr val="FFFFFF"/>
-                    </a:solidFill>
-                  </a:tcPr>
-                </a:tc>
-                <a:tc>
-                  <a:txBody>
-                    <a:bodyPr/>
-                    <a:lstStyle/>
-                    <a:p>
-                      <a:pPr>
-                        <a:defRPr b="0" sz="950">
-                          <a:solidFill>
-                            <a:srgbClr val="1E293B"/>
-                          </a:solidFill>
-                        </a:defRPr>
-                      </a:pPr>
-                      <a:r>
-                        <a:t>7.02 min</a:t>
-                      </a:r>
-                    </a:p>
-                  </a:txBody>
-                  <a:tcPr>
-                    <a:solidFill>
-                      <a:srgbClr val="FFFFFF"/>
-                    </a:solidFill>
-                  </a:tcPr>
-                </a:tc>
-              </a:tr>
-            </a:tbl>
-          </a:graphicData>
-        </a:graphic>
-      </p:graphicFrame>
+      <p:sp>
+        <p:nvSpPr>
+          <p:cNvPr id="4" name="Rectangle 3"/>
+          <p:cNvSpPr/>
+          <p:nvPr/>
+        </p:nvSpPr>
+        <p:spPr>
+          <a:xfrm>
+            <a:off x="731520" y="4709160"/>
+            <a:ext cx="5120640" cy="1828800"/>
+          </a:xfrm>
+          <a:prstGeom prst="rect">
+            <a:avLst/>
+          </a:prstGeom>
+          <a:solidFill>
+            <a:srgbClr val="F8FAFC"/>
+          </a:solidFill>
+          <a:ln w="12700">
+            <a:solidFill>
+              <a:srgbClr val="E2E8F0"/>
+            </a:solidFill>
+          </a:ln>
+        </p:spPr>
+        <p:style>
+          <a:lnRef idx="1">
+            <a:schemeClr val="accent1"/>
+          </a:lnRef>
+          <a:fillRef idx="3">
+            <a:schemeClr val="accent1"/>
+          </a:fillRef>
+          <a:effectRef idx="2">
+            <a:schemeClr val="accent1"/>
+          </a:effectRef>
+          <a:fontRef idx="minor">
+            <a:schemeClr val="lt1"/>
+          </a:fontRef>
+        </p:style>
+        <p:txBody>
+          <a:bodyPr rtlCol="0" anchor="ctr"/>
+          <a:lstStyle/>
+          <a:p>
+            <a:pPr algn="ctr"/>
+          </a:p>
+        </p:txBody>
+      </p:sp>
+      <p:sp>
+        <p:nvSpPr>
+          <p:cNvPr id="5" name="TextBox 4"/>
+          <p:cNvSpPr txBox="1"/>
+          <p:nvPr/>
+        </p:nvSpPr>
+        <p:spPr>
+          <a:xfrm>
+            <a:off x="914400" y="4818888"/>
+            <a:ext cx="4754880" cy="1609344"/>
+          </a:xfrm>
+          <a:prstGeom prst="rect">
+            <a:avLst/>
+          </a:prstGeom>
+          <a:noFill/>
+        </p:spPr>
+        <p:txBody>
+          <a:bodyPr wrap="square">
+            <a:spAutoFit/>
+          </a:bodyPr>
+          <a:lstStyle/>
+          <a:p>
+            <a:pPr>
+              <a:spcAft>
+                <a:spcPts val="400"/>
+              </a:spcAft>
+              <a:defRPr sz="1200" b="1">
+                <a:solidFill>
+                  <a:srgbClr val="0F172A"/>
+                </a:solidFill>
+              </a:defRPr>
+            </a:pPr>
+            <a:r>
+              <a:t>Graph 9: R-Squared Comparison</a:t>
+            </a:r>
+          </a:p>
+          <a:p>
+            <a:pPr>
+              <a:spcAft>
+                <a:spcPts val="300"/>
+              </a:spcAft>
+              <a:defRPr sz="1000">
+                <a:solidFill>
+                  <a:srgbClr val="1E293B"/>
+                </a:solidFill>
+              </a:defRPr>
+            </a:pPr>
+            <a:r>
+              <a:t>- Top Performer: Gradient Boosting achieves the highest R2 score of 0.755 (5-Fold CV R2 = 0.778).</a:t>
+            </a:r>
+          </a:p>
+          <a:p>
+            <a:pPr>
+              <a:spcAft>
+                <a:spcPts val="300"/>
+              </a:spcAft>
+              <a:defRPr sz="1000">
+                <a:solidFill>
+                  <a:srgbClr val="1E293B"/>
+                </a:solidFill>
+              </a:defRPr>
+            </a:pPr>
+            <a:r>
+              <a:t>- Polynomial Competitiveness: Polynomial regression (R2 = 0.754) closely matches tree boosting by capturing 2nd-degree interactions.</a:t>
+            </a:r>
+          </a:p>
+          <a:p>
+            <a:pPr>
+              <a:spcAft>
+                <a:spcPts val="300"/>
+              </a:spcAft>
+              <a:defRPr sz="1000">
+                <a:solidFill>
+                  <a:srgbClr val="1E293B"/>
+                </a:solidFill>
+              </a:defRPr>
+            </a:pPr>
+            <a:r>
+              <a:t>- Tree Weakness: Single Decision Tree lags at R2 = 0.659 due to stepwise variance.</a:t>
+            </a:r>
+          </a:p>
+        </p:txBody>
+      </p:sp>
+      <p:pic>
+        <p:nvPicPr>
+          <p:cNvPr id="6" name="Picture 5" descr="10_rmse_mae_comparison.png"/>
+          <p:cNvPicPr>
+            <a:picLocks noChangeAspect="1"/>
+          </p:cNvPicPr>
+          <p:nvPr/>
+        </p:nvPicPr>
+        <p:blipFill>
+          <a:blip r:embed="rId3"/>
+          <a:stretch>
+            <a:fillRect/>
+          </a:stretch>
+        </p:blipFill>
+        <p:spPr>
+          <a:xfrm>
+            <a:off x="6309360" y="1417320"/>
+            <a:ext cx="5120640" cy="3435330"/>
+          </a:xfrm>
+          <a:prstGeom prst="rect">
+            <a:avLst/>
+          </a:prstGeom>
+        </p:spPr>
+      </p:pic>
+      <p:sp>
+        <p:nvSpPr>
+          <p:cNvPr id="7" name="Rectangle 6"/>
+          <p:cNvSpPr/>
+          <p:nvPr/>
+        </p:nvSpPr>
+        <p:spPr>
+          <a:xfrm>
+            <a:off x="6309360" y="4709160"/>
+            <a:ext cx="5120640" cy="1828800"/>
+          </a:xfrm>
+          <a:prstGeom prst="rect">
+            <a:avLst/>
+          </a:prstGeom>
+          <a:solidFill>
+            <a:srgbClr val="F8FAFC"/>
+          </a:solidFill>
+          <a:ln w="12700">
+            <a:solidFill>
+              <a:srgbClr val="E2E8F0"/>
+            </a:solidFill>
+          </a:ln>
+        </p:spPr>
+        <p:style>
+          <a:lnRef idx="1">
+            <a:schemeClr val="accent1"/>
+          </a:lnRef>
+          <a:fillRef idx="3">
+            <a:schemeClr val="accent1"/>
+          </a:fillRef>
+          <a:effectRef idx="2">
+            <a:schemeClr val="accent1"/>
+          </a:effectRef>
+          <a:fontRef idx="minor">
+            <a:schemeClr val="lt1"/>
+          </a:fontRef>
+        </p:style>
+        <p:txBody>
+          <a:bodyPr rtlCol="0" anchor="ctr"/>
+          <a:lstStyle/>
+          <a:p>
+            <a:pPr algn="ctr"/>
+          </a:p>
+        </p:txBody>
+      </p:sp>
+      <p:sp>
+        <p:nvSpPr>
+          <p:cNvPr id="8" name="TextBox 7"/>
+          <p:cNvSpPr txBox="1"/>
+          <p:nvPr/>
+        </p:nvSpPr>
+        <p:spPr>
+          <a:xfrm>
+            <a:off x="6492240" y="4818888"/>
+            <a:ext cx="4754880" cy="1609344"/>
+          </a:xfrm>
+          <a:prstGeom prst="rect">
+            <a:avLst/>
+          </a:prstGeom>
+          <a:noFill/>
+        </p:spPr>
+        <p:txBody>
+          <a:bodyPr wrap="square">
+            <a:spAutoFit/>
+          </a:bodyPr>
+          <a:lstStyle/>
+          <a:p>
+            <a:pPr>
+              <a:spcAft>
+                <a:spcPts val="400"/>
+              </a:spcAft>
+              <a:defRPr sz="1200" b="1">
+                <a:solidFill>
+                  <a:srgbClr val="0F172A"/>
+                </a:solidFill>
+              </a:defRPr>
+            </a:pPr>
+            <a:r>
+              <a:t>Graph 10: RMSE vs MAE Across Models</a:t>
+            </a:r>
+          </a:p>
+          <a:p>
+            <a:pPr>
+              <a:spcAft>
+                <a:spcPts val="300"/>
+              </a:spcAft>
+              <a:defRPr sz="1000">
+                <a:solidFill>
+                  <a:srgbClr val="1E293B"/>
+                </a:solidFill>
+              </a:defRPr>
+            </a:pPr>
+            <a:r>
+              <a:t>- Lowest Absolute Error: Gradient Boosting achieves lowest MAE (5.02 min) and lowest RMSE (9.36 min).</a:t>
+            </a:r>
+          </a:p>
+          <a:p>
+            <a:pPr>
+              <a:spcAft>
+                <a:spcPts val="300"/>
+              </a:spcAft>
+              <a:defRPr sz="1000">
+                <a:solidFill>
+                  <a:srgbClr val="1E293B"/>
+                </a:solidFill>
+              </a:defRPr>
+            </a:pPr>
+            <a:r>
+              <a:t>- Error Ranking: Gradient Boosting &lt; Polynomial Reg &lt; Random Forest &lt; Linear Reg &lt; Decision Tree.</a:t>
+            </a:r>
+          </a:p>
+          <a:p>
+            <a:pPr>
+              <a:spcAft>
+                <a:spcPts val="300"/>
+              </a:spcAft>
+              <a:defRPr sz="1000">
+                <a:solidFill>
+                  <a:srgbClr val="1E293B"/>
+                </a:solidFill>
+              </a:defRPr>
+            </a:pPr>
+            <a:r>
+              <a:t>- Cross-Validation Stability: Fold-to-fold variance remained under 0.015, verifying consistent generalization.</a:t>
+            </a:r>
+          </a:p>
+        </p:txBody>
+      </p:sp>
     </p:spTree>
   </p:cSld>
   <p:clrMapOvr>

</xml_diff>